<commit_message>
Add a few more things
</commit_message>
<xml_diff>
--- a/Slides/MiCM-Workshop-GWAS-and-Polygenic-Risk-Score.pptx
+++ b/Slides/MiCM-Workshop-GWAS-and-Polygenic-Risk-Score.pptx
@@ -9,7 +9,7 @@
   </p:notesMasterIdLst>
   <p:sldIdLst>
     <p:sldId id="256" r:id="rId2"/>
-    <p:sldId id="262" r:id="rId3"/>
+    <p:sldId id="321" r:id="rId3"/>
     <p:sldId id="259" r:id="rId4"/>
     <p:sldId id="260" r:id="rId5"/>
     <p:sldId id="301" r:id="rId6"/>
@@ -237,7 +237,7 @@
           <a:p>
             <a:fld id="{217E5156-1B5D-054E-B5B2-E1B1BA160252}" type="datetimeFigureOut">
               <a:rPr lang="fr-FR" smtClean="0"/>
-              <a:t>10/08/2025</a:t>
+              <a:t>09/03/2026</a:t>
             </a:fld>
             <a:endParaRPr lang="fr-FR"/>
           </a:p>
@@ -530,7 +530,7 @@
               </a:spcAft>
               <a:buNone/>
             </a:pPr>
-            <a:endParaRPr/>
+            <a:endParaRPr dirty="0"/>
           </a:p>
         </p:txBody>
       </p:sp>
@@ -646,7 +646,7 @@
               </a:spcAft>
               <a:buNone/>
             </a:pPr>
-            <a:endParaRPr/>
+            <a:endParaRPr dirty="0"/>
           </a:p>
         </p:txBody>
       </p:sp>
@@ -761,7 +761,7 @@
               </a:spcAft>
               <a:buNone/>
             </a:pPr>
-            <a:endParaRPr/>
+            <a:endParaRPr dirty="0"/>
           </a:p>
         </p:txBody>
       </p:sp>
@@ -865,7 +865,7 @@
               </a:spcAft>
               <a:buNone/>
             </a:pPr>
-            <a:endParaRPr/>
+            <a:endParaRPr dirty="0"/>
           </a:p>
         </p:txBody>
       </p:sp>
@@ -1010,7 +1010,7 @@
               </a:spcAft>
               <a:buNone/>
             </a:pPr>
-            <a:endParaRPr/>
+            <a:endParaRPr dirty="0"/>
           </a:p>
         </p:txBody>
       </p:sp>
@@ -1160,7 +1160,7 @@
               </a:spcAft>
               <a:buNone/>
             </a:pPr>
-            <a:endParaRPr/>
+            <a:endParaRPr dirty="0"/>
           </a:p>
         </p:txBody>
       </p:sp>
@@ -1310,7 +1310,7 @@
               </a:spcAft>
               <a:buNone/>
             </a:pPr>
-            <a:endParaRPr/>
+            <a:endParaRPr dirty="0"/>
           </a:p>
         </p:txBody>
       </p:sp>
@@ -1460,7 +1460,7 @@
               </a:spcAft>
               <a:buNone/>
             </a:pPr>
-            <a:endParaRPr/>
+            <a:endParaRPr dirty="0"/>
           </a:p>
         </p:txBody>
       </p:sp>
@@ -1619,16 +1619,7 @@
           </a:bodyPr>
           <a:lstStyle/>
           <a:p>
-            <a:pPr marL="0" lvl="0" indent="0" algn="l" rtl="0">
-              <a:spcBef>
-                <a:spcPts val="0"/>
-              </a:spcBef>
-              <a:spcAft>
-                <a:spcPts val="0"/>
-              </a:spcAft>
-              <a:buNone/>
-            </a:pPr>
-            <a:endParaRPr/>
+            <a:endParaRPr dirty="0"/>
           </a:p>
         </p:txBody>
       </p:sp>
@@ -1807,7 +1798,7 @@
               </a:spcAft>
               <a:buNone/>
             </a:pPr>
-            <a:endParaRPr/>
+            <a:endParaRPr dirty="0"/>
           </a:p>
         </p:txBody>
       </p:sp>
@@ -1986,7 +1977,7 @@
               </a:spcAft>
               <a:buNone/>
             </a:pPr>
-            <a:endParaRPr/>
+            <a:endParaRPr dirty="0"/>
           </a:p>
         </p:txBody>
       </p:sp>
@@ -2074,7 +2065,7 @@
       </p:grpSpPr>
       <p:sp>
         <p:nvSpPr>
-          <p:cNvPr id="2" name="Espace réservé de l'image des diapositives 1"/>
+          <p:cNvPr id="2" name="Slide Image Placeholder 1"/>
           <p:cNvSpPr>
             <a:spLocks noGrp="1" noRot="1" noChangeAspect="1"/>
           </p:cNvSpPr>
@@ -2082,16 +2073,11 @@
             <p:ph type="sldImg"/>
           </p:nvPr>
         </p:nvSpPr>
-        <p:spPr>
-          <a:xfrm>
-            <a:off x="1371600" y="1143000"/>
-            <a:ext cx="4114800" cy="3086100"/>
-          </a:xfrm>
-        </p:spPr>
-      </p:sp>
-      <p:sp>
-        <p:nvSpPr>
-          <p:cNvPr id="3" name="Espace réservé des notes 2"/>
+        <p:spPr/>
+      </p:sp>
+      <p:sp>
+        <p:nvSpPr>
+          <p:cNvPr id="3" name="Notes Placeholder 2"/>
           <p:cNvSpPr>
             <a:spLocks noGrp="1"/>
           </p:cNvSpPr>
@@ -2104,165 +2090,53 @@
           <a:bodyPr/>
           <a:lstStyle/>
           <a:p>
-            <a:pPr marL="0" marR="0" lvl="0" indent="0" algn="l" defTabSz="914400" rtl="0" eaLnBrk="1" fontAlgn="auto" latinLnBrk="0" hangingPunct="1">
-              <a:lnSpc>
-                <a:spcPct val="100000"/>
-              </a:lnSpc>
-              <a:spcBef>
-                <a:spcPts val="0"/>
-              </a:spcBef>
-              <a:spcAft>
-                <a:spcPts val="0"/>
-              </a:spcAft>
-              <a:buClrTx/>
-              <a:buSzTx/>
-              <a:buFontTx/>
-              <a:buNone/>
-              <a:tabLst/>
-              <a:defRPr/>
-            </a:pPr>
-            <a:r>
-              <a:rPr lang="en-CA" sz="1200" dirty="0"/>
-              <a:t>The McGill initiative on Computational Medicine was formed in 2017 and aims to deliver inter-disciplinary research programs and empower the use of data in health research and health care delivery</a:t>
-            </a:r>
-          </a:p>
-          <a:p>
-            <a:pPr marL="0" marR="0" lvl="0" indent="0" algn="l" defTabSz="914400" rtl="0" eaLnBrk="1" fontAlgn="auto" latinLnBrk="0" hangingPunct="1">
-              <a:lnSpc>
-                <a:spcPct val="100000"/>
-              </a:lnSpc>
-              <a:spcBef>
-                <a:spcPts val="0"/>
-              </a:spcBef>
-              <a:spcAft>
-                <a:spcPts val="0"/>
-              </a:spcAft>
-              <a:buClrTx/>
-              <a:buSzTx/>
-              <a:buFontTx/>
-              <a:buNone/>
-              <a:tabLst/>
-              <a:defRPr/>
-            </a:pPr>
-            <a:r>
-              <a:rPr lang="en-CA" sz="1200" dirty="0"/>
-              <a:t>Located at the Genome Center</a:t>
-            </a:r>
-          </a:p>
-          <a:p>
-            <a:pPr marL="0" marR="0" lvl="0" indent="0" algn="l" defTabSz="914400" rtl="0" eaLnBrk="1" fontAlgn="auto" latinLnBrk="0" hangingPunct="1">
-              <a:lnSpc>
-                <a:spcPct val="100000"/>
-              </a:lnSpc>
-              <a:spcBef>
-                <a:spcPts val="0"/>
-              </a:spcBef>
-              <a:spcAft>
-                <a:spcPts val="0"/>
-              </a:spcAft>
-              <a:buClrTx/>
-              <a:buSzTx/>
-              <a:buFontTx/>
-              <a:buNone/>
-              <a:tabLst/>
-              <a:defRPr/>
-            </a:pPr>
-            <a:endParaRPr lang="en-CA" sz="1200" dirty="0"/>
-          </a:p>
-          <a:p>
-            <a:pPr marL="0" marR="0" lvl="0" indent="0" algn="l" defTabSz="914400" rtl="0" eaLnBrk="1" fontAlgn="auto" latinLnBrk="0" hangingPunct="1">
-              <a:lnSpc>
-                <a:spcPct val="100000"/>
-              </a:lnSpc>
-              <a:spcBef>
-                <a:spcPts val="0"/>
-              </a:spcBef>
-              <a:spcAft>
-                <a:spcPts val="0"/>
-              </a:spcAft>
-              <a:buClrTx/>
-              <a:buSzTx/>
-              <a:buFontTx/>
-              <a:buNone/>
-              <a:tabLst/>
-              <a:defRPr/>
-            </a:pPr>
-            <a:endParaRPr lang="en-CA" sz="1200" dirty="0"/>
-          </a:p>
-          <a:p>
-            <a:pPr marL="0" marR="0" lvl="0" indent="0" algn="l" defTabSz="914400" rtl="0" eaLnBrk="1" fontAlgn="auto" latinLnBrk="0" hangingPunct="1">
-              <a:lnSpc>
-                <a:spcPct val="100000"/>
-              </a:lnSpc>
-              <a:spcBef>
-                <a:spcPts val="0"/>
-              </a:spcBef>
-              <a:spcAft>
-                <a:spcPts val="0"/>
-              </a:spcAft>
-              <a:buClrTx/>
-              <a:buSzTx/>
-              <a:buFontTx/>
-              <a:buNone/>
-              <a:tabLst/>
-              <a:defRPr/>
-            </a:pPr>
-            <a:r>
-              <a:rPr lang="en-CA" sz="1200" dirty="0"/>
-              <a:t>They have a newsletter were you can subscribe to </a:t>
-            </a:r>
-          </a:p>
-          <a:p>
-            <a:pPr marL="0" marR="0" lvl="0" indent="0" algn="l" defTabSz="914400" rtl="0" eaLnBrk="1" fontAlgn="auto" latinLnBrk="0" hangingPunct="1">
-              <a:lnSpc>
-                <a:spcPct val="100000"/>
-              </a:lnSpc>
-              <a:spcBef>
-                <a:spcPts val="0"/>
-              </a:spcBef>
-              <a:spcAft>
-                <a:spcPts val="0"/>
-              </a:spcAft>
-              <a:buClrTx/>
-              <a:buSzTx/>
-              <a:buFontTx/>
-              <a:buNone/>
-              <a:tabLst/>
-              <a:defRPr/>
-            </a:pPr>
-            <a:endParaRPr lang="en-CA" sz="1200" dirty="0"/>
-          </a:p>
-          <a:p>
-            <a:pPr marL="0" marR="0" lvl="0" indent="0" algn="l" defTabSz="914400" rtl="0" eaLnBrk="1" fontAlgn="auto" latinLnBrk="0" hangingPunct="1">
-              <a:lnSpc>
-                <a:spcPct val="100000"/>
-              </a:lnSpc>
-              <a:spcBef>
-                <a:spcPts val="0"/>
-              </a:spcBef>
-              <a:spcAft>
-                <a:spcPts val="0"/>
-              </a:spcAft>
-              <a:buClrTx/>
-              <a:buSzTx/>
-              <a:buFontTx/>
-              <a:buNone/>
-              <a:tabLst/>
-              <a:defRPr/>
-            </a:pPr>
-            <a:r>
-              <a:rPr lang="en-CA" sz="1200" dirty="0"/>
-              <a:t>more info on the web site</a:t>
-            </a:r>
-          </a:p>
-          <a:p>
-            <a:endParaRPr lang="en-CA" dirty="0"/>
+            <a:r>
+              <a:rPr lang="en-US" b="0" i="0" dirty="0" err="1">
+                <a:solidFill>
+                  <a:srgbClr val="000000"/>
+                </a:solidFill>
+                <a:effectLst/>
+                <a:latin typeface="McgillSans-Regular"/>
+              </a:rPr>
+              <a:t>MiCM</a:t>
+            </a:r>
+            <a:r>
+              <a:rPr lang="en-US" b="0" i="0" dirty="0">
+                <a:solidFill>
+                  <a:srgbClr val="000000"/>
+                </a:solidFill>
+                <a:effectLst/>
+                <a:latin typeface="McgillSans-Regular"/>
+              </a:rPr>
+              <a:t> aims to advance biomedical research at McGill University by providing workshops and bootcamps on a wide range of computational skills and tools. QLS-</a:t>
+            </a:r>
+            <a:r>
+              <a:rPr lang="en-US" b="0" i="0" dirty="0" err="1">
+                <a:solidFill>
+                  <a:srgbClr val="000000"/>
+                </a:solidFill>
+                <a:effectLst/>
+                <a:latin typeface="McgillSans-Regular"/>
+              </a:rPr>
+              <a:t>MiCM</a:t>
+            </a:r>
+            <a:r>
+              <a:rPr lang="en-US" b="0" i="0" dirty="0">
+                <a:solidFill>
+                  <a:srgbClr val="000000"/>
+                </a:solidFill>
+                <a:effectLst/>
+                <a:latin typeface="McgillSans-Regular"/>
+              </a:rPr>
+              <a:t> integrates clinical data with research in genomics, epidemiology, imaging, and other areas of biology. Our workshops are offered at various proficiency levels – from beginner to advanced – ensuring all researchers can benefit from our platform.</a:t>
+            </a:r>
+            <a:endParaRPr lang="fr-CA" dirty="0"/>
           </a:p>
         </p:txBody>
       </p:sp>
       <p:sp>
         <p:nvSpPr>
-          <p:cNvPr id="4" name="Espace réservé du numéro de diapositive 3"/>
+          <p:cNvPr id="4" name="Slide Number Placeholder 3"/>
           <p:cNvSpPr>
             <a:spLocks noGrp="1"/>
           </p:cNvSpPr>
@@ -2286,7 +2160,7 @@
     </p:spTree>
     <p:extLst>
       <p:ext uri="{BB962C8B-B14F-4D97-AF65-F5344CB8AC3E}">
-        <p14:creationId xmlns:p14="http://schemas.microsoft.com/office/powerpoint/2010/main" val="3840063572"/>
+        <p14:creationId xmlns:p14="http://schemas.microsoft.com/office/powerpoint/2010/main" val="520945049"/>
       </p:ext>
     </p:extLst>
   </p:cSld>
@@ -2389,10 +2263,9 @@
               <a:buNone/>
             </a:pPr>
             <a:r>
-              <a:rPr lang="en-CA"/>
+              <a:rPr lang="en-US" dirty="0"/>
               <a:t>Type 2 diabetes GWAS</a:t>
             </a:r>
-            <a:endParaRPr/>
           </a:p>
           <a:p>
             <a:pPr marL="0" lvl="0" indent="0" algn="l" rtl="0">
@@ -2405,10 +2278,9 @@
               <a:buNone/>
             </a:pPr>
             <a:r>
-              <a:rPr lang="en-CA"/>
+              <a:rPr lang="en-US" dirty="0"/>
               <a:t>https://www.researchgate.net/figure/Trans-ethnic-and-ancestry-specific-GWAS-Manhattan-plots-a-d-Each-graph-represents-a_fig1_342184407</a:t>
             </a:r>
-            <a:endParaRPr/>
           </a:p>
         </p:txBody>
       </p:sp>
@@ -2558,7 +2430,7 @@
               </a:spcAft>
               <a:buNone/>
             </a:pPr>
-            <a:endParaRPr/>
+            <a:endParaRPr dirty="0"/>
           </a:p>
         </p:txBody>
       </p:sp>
@@ -2708,7 +2580,11 @@
               </a:spcAft>
               <a:buNone/>
             </a:pPr>
-            <a:endParaRPr/>
+            <a:r>
+              <a:rPr lang="en-CA" dirty="0"/>
+              <a:t>  </a:t>
+            </a:r>
+            <a:endParaRPr dirty="0"/>
           </a:p>
         </p:txBody>
       </p:sp>
@@ -2829,7 +2705,7 @@
               </a:spcAft>
               <a:buNone/>
             </a:pPr>
-            <a:endParaRPr/>
+            <a:endParaRPr dirty="0"/>
           </a:p>
         </p:txBody>
       </p:sp>
@@ -2986,11 +2862,11 @@
               <a:buNone/>
             </a:pPr>
             <a:r>
-              <a:rPr lang="en-CA"/>
+              <a:rPr lang="en-CA" dirty="0"/>
               <a:t>Figure from: </a:t>
             </a:r>
             <a:r>
-              <a:rPr lang="en-CA" u="sng">
+              <a:rPr lang="en-CA" u="sng" dirty="0">
                 <a:solidFill>
                   <a:schemeClr val="hlink"/>
                 </a:solidFill>
@@ -2998,7 +2874,7 @@
               </a:rPr>
               <a:t>https://www.genome.gov/Health/Genomics-and-Medicine/Polygenic-risk-scores</a:t>
             </a:r>
-            <a:endParaRPr/>
+            <a:endParaRPr dirty="0"/>
           </a:p>
           <a:p>
             <a:pPr marL="0" lvl="0" indent="0" algn="l" rtl="0">
@@ -3010,7 +2886,7 @@
               </a:spcAft>
               <a:buNone/>
             </a:pPr>
-            <a:endParaRPr/>
+            <a:endParaRPr dirty="0"/>
           </a:p>
           <a:p>
             <a:pPr marL="0" lvl="0" indent="0" algn="l" rtl="0">
@@ -3022,7 +2898,7 @@
               </a:spcAft>
               <a:buNone/>
             </a:pPr>
-            <a:endParaRPr/>
+            <a:endParaRPr dirty="0"/>
           </a:p>
         </p:txBody>
       </p:sp>
@@ -3172,7 +3048,7 @@
               </a:spcAft>
               <a:buNone/>
             </a:pPr>
-            <a:endParaRPr/>
+            <a:endParaRPr dirty="0"/>
           </a:p>
         </p:txBody>
       </p:sp>
@@ -3322,7 +3198,7 @@
               </a:spcAft>
               <a:buNone/>
             </a:pPr>
-            <a:endParaRPr/>
+            <a:endParaRPr dirty="0"/>
           </a:p>
         </p:txBody>
       </p:sp>
@@ -3472,7 +3348,7 @@
               </a:spcAft>
               <a:buNone/>
             </a:pPr>
-            <a:endParaRPr/>
+            <a:endParaRPr dirty="0"/>
           </a:p>
         </p:txBody>
       </p:sp>
@@ -3622,7 +3498,7 @@
               </a:spcAft>
               <a:buNone/>
             </a:pPr>
-            <a:endParaRPr/>
+            <a:endParaRPr dirty="0"/>
           </a:p>
         </p:txBody>
       </p:sp>
@@ -3927,7 +3803,7 @@
               </a:spcAft>
               <a:buNone/>
             </a:pPr>
-            <a:endParaRPr/>
+            <a:endParaRPr dirty="0"/>
           </a:p>
         </p:txBody>
       </p:sp>
@@ -4043,7 +3919,7 @@
               </a:spcAft>
               <a:buNone/>
             </a:pPr>
-            <a:endParaRPr/>
+            <a:endParaRPr dirty="0"/>
           </a:p>
         </p:txBody>
       </p:sp>
@@ -4275,6 +4151,90 @@
 </file>
 
 <file path=ppt/notesSlides/notesSlide32.xml><?xml version="1.0" encoding="utf-8"?>
+<p:notes xmlns:a="http://schemas.openxmlformats.org/drawingml/2006/main" xmlns:r="http://schemas.openxmlformats.org/officeDocument/2006/relationships" xmlns:p="http://schemas.openxmlformats.org/presentationml/2006/main">
+  <p:cSld>
+    <p:spTree>
+      <p:nvGrpSpPr>
+        <p:cNvPr id="1" name=""/>
+        <p:cNvGrpSpPr/>
+        <p:nvPr/>
+      </p:nvGrpSpPr>
+      <p:grpSpPr>
+        <a:xfrm>
+          <a:off x="0" y="0"/>
+          <a:ext cx="0" cy="0"/>
+          <a:chOff x="0" y="0"/>
+          <a:chExt cx="0" cy="0"/>
+        </a:xfrm>
+      </p:grpSpPr>
+      <p:sp>
+        <p:nvSpPr>
+          <p:cNvPr id="2" name="Slide Image Placeholder 1"/>
+          <p:cNvSpPr>
+            <a:spLocks noGrp="1" noRot="1" noChangeAspect="1"/>
+          </p:cNvSpPr>
+          <p:nvPr>
+            <p:ph type="sldImg"/>
+          </p:nvPr>
+        </p:nvSpPr>
+        <p:spPr/>
+      </p:sp>
+      <p:sp>
+        <p:nvSpPr>
+          <p:cNvPr id="3" name="Notes Placeholder 2"/>
+          <p:cNvSpPr>
+            <a:spLocks noGrp="1"/>
+          </p:cNvSpPr>
+          <p:nvPr>
+            <p:ph type="body" idx="1"/>
+          </p:nvPr>
+        </p:nvSpPr>
+        <p:spPr/>
+        <p:txBody>
+          <a:bodyPr/>
+          <a:lstStyle/>
+          <a:p>
+            <a:endParaRPr lang="en-CA" dirty="0"/>
+          </a:p>
+        </p:txBody>
+      </p:sp>
+      <p:sp>
+        <p:nvSpPr>
+          <p:cNvPr id="4" name="Slide Number Placeholder 3"/>
+          <p:cNvSpPr>
+            <a:spLocks noGrp="1"/>
+          </p:cNvSpPr>
+          <p:nvPr>
+            <p:ph type="sldNum" sz="quarter" idx="5"/>
+          </p:nvPr>
+        </p:nvSpPr>
+        <p:spPr/>
+        <p:txBody>
+          <a:bodyPr/>
+          <a:lstStyle/>
+          <a:p>
+            <a:fld id="{DACBD60B-517C-4242-AE46-E1BD2D086542}" type="slidenum">
+              <a:rPr lang="fr-FR" smtClean="0"/>
+              <a:t>32</a:t>
+            </a:fld>
+            <a:endParaRPr lang="fr-FR"/>
+          </a:p>
+        </p:txBody>
+      </p:sp>
+    </p:spTree>
+    <p:extLst>
+      <p:ext uri="{BB962C8B-B14F-4D97-AF65-F5344CB8AC3E}">
+        <p14:creationId xmlns:p14="http://schemas.microsoft.com/office/powerpoint/2010/main" val="2450193839"/>
+      </p:ext>
+    </p:extLst>
+  </p:cSld>
+  <p:clrMapOvr>
+    <a:masterClrMapping/>
+  </p:clrMapOvr>
+</p:notes>
+</file>
+
+<file path=ppt/notesSlides/notesSlide33.xml><?xml version="1.0" encoding="utf-8"?>
 <p:notes xmlns:a="http://schemas.openxmlformats.org/drawingml/2006/main" xmlns:r="http://schemas.openxmlformats.org/officeDocument/2006/relationships" xmlns:p="http://schemas.openxmlformats.org/presentationml/2006/main" showMasterSp="0" showMasterPhAnim="0">
   <p:cSld>
     <p:spTree>
@@ -4325,7 +4285,7 @@
               </a:spcAft>
               <a:buNone/>
             </a:pPr>
-            <a:endParaRPr/>
+            <a:endParaRPr dirty="0"/>
           </a:p>
         </p:txBody>
       </p:sp>
@@ -4429,7 +4389,7 @@
               </a:spcAft>
               <a:buNone/>
             </a:pPr>
-            <a:endParaRPr/>
+            <a:endParaRPr dirty="0"/>
           </a:p>
         </p:txBody>
       </p:sp>
@@ -4545,7 +4505,7 @@
               </a:spcAft>
               <a:buNone/>
             </a:pPr>
-            <a:endParaRPr/>
+            <a:endParaRPr dirty="0"/>
           </a:p>
         </p:txBody>
       </p:sp>
@@ -4719,7 +4679,7 @@
               </a:spcAft>
               <a:buNone/>
             </a:pPr>
-            <a:endParaRPr/>
+            <a:endParaRPr dirty="0"/>
           </a:p>
         </p:txBody>
       </p:sp>
@@ -4898,7 +4858,7 @@
               </a:spcAft>
               <a:buNone/>
             </a:pPr>
-            <a:endParaRPr/>
+            <a:endParaRPr dirty="0"/>
           </a:p>
         </p:txBody>
       </p:sp>
@@ -5059,7 +5019,7 @@
               </a:spcAft>
               <a:buNone/>
             </a:pPr>
-            <a:endParaRPr/>
+            <a:endParaRPr dirty="0"/>
           </a:p>
         </p:txBody>
       </p:sp>
@@ -5168,7 +5128,7 @@
               </a:spcAft>
               <a:buNone/>
             </a:pPr>
-            <a:endParaRPr/>
+            <a:endParaRPr dirty="0"/>
           </a:p>
         </p:txBody>
       </p:sp>
@@ -7954,8 +7914,8 @@
         </p:nvSpPr>
         <p:spPr>
           <a:xfrm>
-            <a:off x="165136" y="5824977"/>
-            <a:ext cx="3973037" cy="369332"/>
+            <a:off x="165136" y="5037525"/>
+            <a:ext cx="5321264" cy="1200288"/>
           </a:xfrm>
           <a:prstGeom prst="rect">
             <a:avLst/>
@@ -7985,20 +7945,98 @@
                 <a:solidFill>
                   <a:schemeClr val="dk1"/>
                 </a:solidFill>
-                <a:latin typeface="Helvetica Neue Light"/>
+                <a:latin typeface="Arial" panose="020B0604020202020204" pitchFamily="34" charset="0"/>
                 <a:ea typeface="Helvetica Neue Light"/>
-                <a:cs typeface="Helvetica Neue Light"/>
+                <a:cs typeface="Arial" panose="020B0604020202020204" pitchFamily="34" charset="0"/>
                 <a:sym typeface="Helvetica Neue Light"/>
               </a:rPr>
-              <a:t>Workshop Lead: Yuan Ding</a:t>
+              <a:t>Workshop Lead: </a:t>
+            </a:r>
+            <a:r>
+              <a:rPr lang="en-US" sz="1800" b="1" dirty="0">
+                <a:solidFill>
+                  <a:schemeClr val="dk1"/>
+                </a:solidFill>
+                <a:latin typeface="Arial" panose="020B0604020202020204" pitchFamily="34" charset="0"/>
+                <a:ea typeface="Helvetica Neue Light"/>
+                <a:cs typeface="Arial" panose="020B0604020202020204" pitchFamily="34" charset="0"/>
+                <a:sym typeface="Helvetica Neue Light"/>
+              </a:rPr>
+              <a:t>Shucheng (Bangli) Cao</a:t>
+            </a:r>
+          </a:p>
+          <a:p>
+            <a:pPr marL="0" marR="0" lvl="0" indent="0" algn="l" rtl="0">
+              <a:spcBef>
+                <a:spcPts val="0"/>
+              </a:spcBef>
+              <a:spcAft>
+                <a:spcPts val="0"/>
+              </a:spcAft>
+              <a:buNone/>
+            </a:pPr>
+            <a:r>
+              <a:rPr lang="en-US" sz="1800" b="1" dirty="0">
+                <a:solidFill>
+                  <a:schemeClr val="dk1"/>
+                </a:solidFill>
+                <a:latin typeface="Arial" panose="020B0604020202020204" pitchFamily="34" charset="0"/>
+                <a:ea typeface="Helvetica Neue Light"/>
+                <a:cs typeface="Arial" panose="020B0604020202020204" pitchFamily="34" charset="0"/>
+                <a:sym typeface="Helvetica Neue Light"/>
+              </a:rPr>
+              <a:t>Facilitator: Jack Song</a:t>
+            </a:r>
+          </a:p>
+          <a:p>
+            <a:pPr marL="0" marR="0" lvl="0" indent="0" algn="l" rtl="0">
+              <a:spcBef>
+                <a:spcPts val="0"/>
+              </a:spcBef>
+              <a:spcAft>
+                <a:spcPts val="0"/>
+              </a:spcAft>
+              <a:buNone/>
+            </a:pPr>
+            <a:endParaRPr lang="en-US" sz="1800" b="1" dirty="0">
+              <a:solidFill>
+                <a:schemeClr val="dk1"/>
+              </a:solidFill>
+              <a:latin typeface="Arial" panose="020B0604020202020204" pitchFamily="34" charset="0"/>
+              <a:ea typeface="Helvetica Neue Light"/>
+              <a:cs typeface="Arial" panose="020B0604020202020204" pitchFamily="34" charset="0"/>
+              <a:sym typeface="Helvetica Neue Light"/>
+            </a:endParaRPr>
+          </a:p>
+          <a:p>
+            <a:pPr marL="0" marR="0" lvl="0" indent="0" algn="l" rtl="0">
+              <a:spcBef>
+                <a:spcPts val="0"/>
+              </a:spcBef>
+              <a:spcAft>
+                <a:spcPts val="0"/>
+              </a:spcAft>
+              <a:buNone/>
+            </a:pPr>
+            <a:r>
+              <a:rPr lang="en-US" sz="1800" b="1" dirty="0">
+                <a:solidFill>
+                  <a:schemeClr val="dk1"/>
+                </a:solidFill>
+                <a:latin typeface="Arial" panose="020B0604020202020204" pitchFamily="34" charset="0"/>
+                <a:ea typeface="Helvetica Neue Light"/>
+                <a:cs typeface="Arial" panose="020B0604020202020204" pitchFamily="34" charset="0"/>
+                <a:sym typeface="Helvetica Neue Light"/>
+              </a:rPr>
+              <a:t>Slides adapted from material by Yuan Ding</a:t>
             </a:r>
             <a:endParaRPr sz="1801" b="1" dirty="0">
               <a:solidFill>
                 <a:schemeClr val="dk1"/>
               </a:solidFill>
-              <a:latin typeface="Helvetica Neue Light"/>
+              <a:latin typeface="Arial" panose="020B0604020202020204" pitchFamily="34" charset="0"/>
               <a:ea typeface="Helvetica Neue Light"/>
-              <a:cs typeface="Helvetica Neue Light"/>
+              <a:cs typeface="Arial" panose="020B0604020202020204" pitchFamily="34" charset="0"/>
               <a:sym typeface="Helvetica Neue Light"/>
             </a:endParaRPr>
           </a:p>
@@ -8043,20 +8081,20 @@
                 <a:solidFill>
                   <a:schemeClr val="dk1"/>
                 </a:solidFill>
-                <a:latin typeface="Helvetica Neue Light"/>
+                <a:latin typeface="Arial" panose="020B0604020202020204" pitchFamily="34" charset="0"/>
                 <a:ea typeface="Helvetica Neue Light"/>
-                <a:cs typeface="Helvetica Neue Light"/>
+                <a:cs typeface="Arial" panose="020B0604020202020204" pitchFamily="34" charset="0"/>
                 <a:sym typeface="Helvetica Neue Light"/>
               </a:rPr>
-              <a:t>Date: 2025-08-14</a:t>
+              <a:t>Date: 2026-03-12</a:t>
             </a:r>
             <a:endParaRPr sz="1800" b="1" dirty="0">
               <a:solidFill>
                 <a:schemeClr val="dk1"/>
               </a:solidFill>
-              <a:latin typeface="Helvetica Neue Light"/>
+              <a:latin typeface="Arial" panose="020B0604020202020204" pitchFamily="34" charset="0"/>
               <a:ea typeface="Helvetica Neue Light"/>
-              <a:cs typeface="Helvetica Neue Light"/>
+              <a:cs typeface="Arial" panose="020B0604020202020204" pitchFamily="34" charset="0"/>
               <a:sym typeface="Helvetica Neue Light"/>
             </a:endParaRPr>
           </a:p>
@@ -8166,14 +8204,14 @@
           <p:nvPr>
             <p:extLst>
               <p:ext uri="{D42A27DB-BD31-4B8C-83A1-F6EECF244321}">
-                <p14:modId xmlns:p14="http://schemas.microsoft.com/office/powerpoint/2010/main" val="1714053895"/>
+                <p14:modId xmlns:p14="http://schemas.microsoft.com/office/powerpoint/2010/main" val="2320485346"/>
               </p:ext>
             </p:extLst>
           </p:nvPr>
         </p:nvGraphicFramePr>
         <p:xfrm>
-          <a:off x="733150" y="2112150"/>
-          <a:ext cx="7782100" cy="3016444"/>
+          <a:off x="680950" y="1612088"/>
+          <a:ext cx="7782100" cy="4186876"/>
         </p:xfrm>
         <a:graphic>
           <a:graphicData uri="http://schemas.openxmlformats.org/drawingml/2006/table">
@@ -8213,10 +8251,10 @@
                         <a:buNone/>
                       </a:pPr>
                       <a:r>
-                        <a:rPr lang="en-CA" sz="1800" b="1"/>
+                        <a:rPr lang="en-CA" sz="2400" b="1"/>
                         <a:t>Mendelian diseases</a:t>
                       </a:r>
-                      <a:endParaRPr sz="1800" b="1"/>
+                      <a:endParaRPr sz="2400" b="1"/>
                     </a:p>
                   </a:txBody>
                   <a:tcPr marL="91425" marR="91425" marT="91425" marB="91425">
@@ -8276,10 +8314,10 @@
                         <a:buNone/>
                       </a:pPr>
                       <a:r>
-                        <a:rPr lang="en-CA" sz="1800" b="1" dirty="0"/>
+                        <a:rPr lang="en-CA" sz="2400" b="1" dirty="0"/>
                         <a:t>Complex diseases</a:t>
                       </a:r>
-                      <a:endParaRPr sz="1800" b="1" dirty="0"/>
+                      <a:endParaRPr sz="2400" b="1" dirty="0"/>
                     </a:p>
                   </a:txBody>
                   <a:tcPr marL="91425" marR="91425" marT="91425" marB="91425">
@@ -8354,7 +8392,7 @@
                         <a:buChar char="●"/>
                       </a:pPr>
                       <a:r>
-                        <a:rPr lang="en-CA" dirty="0">
+                        <a:rPr lang="en-CA" sz="2400" dirty="0">
                           <a:latin typeface="Helvetica Neue"/>
                         </a:rPr>
                         <a:t>Cystic fibrosis</a:t>
@@ -8379,7 +8417,7 @@
                         <a:buChar char="●"/>
                       </a:pPr>
                       <a:r>
-                        <a:rPr lang="en-CA" altLang="zh-CN" sz="1800" b="0" i="0" kern="1200" dirty="0">
+                        <a:rPr lang="en-CA" altLang="zh-CN" sz="2400" b="0" i="0" kern="1200" dirty="0">
                           <a:solidFill>
                             <a:schemeClr val="tx1"/>
                           </a:solidFill>
@@ -8410,7 +8448,7 @@
                         <a:buChar char="●"/>
                       </a:pPr>
                       <a:r>
-                        <a:rPr lang="en-CA" dirty="0">
+                        <a:rPr lang="en-CA" sz="2400" dirty="0">
                           <a:latin typeface="Helvetica Neue"/>
                         </a:rPr>
                         <a:t>Color blindness</a:t>
@@ -8435,12 +8473,12 @@
                         <a:buChar char="●"/>
                       </a:pPr>
                       <a:r>
-                        <a:rPr lang="en-CA" dirty="0">
+                        <a:rPr lang="en-CA" sz="2400" dirty="0">
                           <a:latin typeface="Helvetica Neue"/>
                         </a:rPr>
                         <a:t>Hemophilia </a:t>
                       </a:r>
-                      <a:endParaRPr dirty="0">
+                      <a:endParaRPr sz="2400" dirty="0">
                         <a:latin typeface="Helvetica Neue"/>
                       </a:endParaRPr>
                     </a:p>
@@ -8507,7 +8545,7 @@
                         <a:buChar char="●"/>
                       </a:pPr>
                       <a:r>
-                        <a:rPr lang="en-US" sz="1800" dirty="0">
+                        <a:rPr lang="en-US" sz="2400" dirty="0">
                           <a:solidFill>
                             <a:schemeClr val="dk1"/>
                           </a:solidFill>
@@ -8538,7 +8576,7 @@
                         <a:buChar char="●"/>
                       </a:pPr>
                       <a:r>
-                        <a:rPr lang="en-US" sz="1800" dirty="0">
+                        <a:rPr lang="en-US" sz="2400" dirty="0">
                           <a:solidFill>
                             <a:schemeClr val="dk1"/>
                           </a:solidFill>
@@ -8571,7 +8609,7 @@
                         <a:defRPr/>
                       </a:pPr>
                       <a:r>
-                        <a:rPr lang="en-US" altLang="zh-CN" sz="1800" dirty="0">
+                        <a:rPr lang="en-US" altLang="zh-CN" sz="2400" dirty="0">
                           <a:solidFill>
                             <a:schemeClr val="dk1"/>
                           </a:solidFill>
@@ -8582,7 +8620,7 @@
                         </a:rPr>
                         <a:t>Type 1 diabetes</a:t>
                       </a:r>
-                      <a:endParaRPr lang="en-US" sz="1800" dirty="0">
+                      <a:endParaRPr lang="en-US" sz="2400" dirty="0">
                         <a:solidFill>
                           <a:schemeClr val="dk1"/>
                         </a:solidFill>
@@ -8611,7 +8649,7 @@
                         <a:buChar char="●"/>
                       </a:pPr>
                       <a:r>
-                        <a:rPr lang="en-US" sz="1800" dirty="0">
+                        <a:rPr lang="en-US" sz="2400" dirty="0">
                           <a:solidFill>
                             <a:schemeClr val="dk1"/>
                           </a:solidFill>
@@ -8642,7 +8680,7 @@
                         <a:buChar char="●"/>
                       </a:pPr>
                       <a:r>
-                        <a:rPr lang="en-US" sz="1800" dirty="0">
+                        <a:rPr lang="en-US" sz="2400" dirty="0">
                           <a:solidFill>
                             <a:schemeClr val="dk1"/>
                           </a:solidFill>
@@ -8673,7 +8711,7 @@
                         <a:buChar char="●"/>
                       </a:pPr>
                       <a:r>
-                        <a:rPr lang="en-US" sz="1800" dirty="0">
+                        <a:rPr lang="en-US" sz="2400" dirty="0">
                           <a:solidFill>
                             <a:schemeClr val="dk1"/>
                           </a:solidFill>
@@ -8703,7 +8741,7 @@
                         <a:buFont typeface="Helvetica Neue"/>
                         <a:buNone/>
                       </a:pPr>
-                      <a:endParaRPr lang="en-US" sz="1800" dirty="0">
+                      <a:endParaRPr lang="en-US" sz="2400" dirty="0">
                         <a:solidFill>
                           <a:schemeClr val="dk1"/>
                         </a:solidFill>
@@ -8731,7 +8769,7 @@
                         <a:buFont typeface="Helvetica Neue"/>
                         <a:buChar char="●"/>
                       </a:pPr>
-                      <a:endParaRPr sz="1800" dirty="0">
+                      <a:endParaRPr sz="2400" dirty="0">
                         <a:solidFill>
                           <a:schemeClr val="dk1"/>
                         </a:solidFill>
@@ -8751,7 +8789,7 @@
                         </a:spcAft>
                         <a:buNone/>
                       </a:pPr>
-                      <a:endParaRPr dirty="0"/>
+                      <a:endParaRPr sz="2400" dirty="0"/>
                     </a:p>
                   </a:txBody>
                   <a:tcPr marL="91425" marR="91425" marT="91425" marB="91425">
@@ -8899,7 +8937,7 @@
         </p:nvSpPr>
         <p:spPr>
           <a:xfrm>
-            <a:off x="519343" y="1650354"/>
+            <a:off x="519343" y="1230300"/>
             <a:ext cx="7996007" cy="4397399"/>
           </a:xfrm>
           <a:prstGeom prst="rect">
@@ -8930,7 +8968,7 @@
               <a:buChar char="●"/>
             </a:pPr>
             <a:r>
-              <a:rPr lang="en-CA" dirty="0"/>
+              <a:rPr lang="en-CA" sz="2400" dirty="0"/>
               <a:t>How much phenotypic variance can be explained by SNPs</a:t>
             </a:r>
           </a:p>
@@ -8948,7 +8986,7 @@
               <a:buSzPts val="1800"/>
               <a:buNone/>
             </a:pPr>
-            <a:endParaRPr dirty="0"/>
+            <a:endParaRPr sz="2400" dirty="0"/>
           </a:p>
           <a:p>
             <a:pPr marL="457200" lvl="0" indent="-342900" algn="l" rtl="0">
@@ -8965,10 +9003,10 @@
               <a:buChar char="●"/>
             </a:pPr>
             <a:r>
-              <a:rPr lang="en-CA" dirty="0"/>
+              <a:rPr lang="en-CA" sz="2400" dirty="0"/>
               <a:t>High SNP-based heritability: common variants play a big role in the genetic architecture of the trait</a:t>
             </a:r>
-            <a:endParaRPr dirty="0"/>
+            <a:endParaRPr sz="2400" dirty="0"/>
           </a:p>
         </p:txBody>
       </p:sp>
@@ -9168,10 +9206,10 @@
               <a:buChar char="●"/>
             </a:pPr>
             <a:r>
-              <a:rPr lang="en-CA" dirty="0"/>
+              <a:rPr lang="en-CA" sz="2400" dirty="0"/>
               <a:t>SNP heritability does not capture variance explained due to:</a:t>
             </a:r>
-            <a:endParaRPr dirty="0"/>
+            <a:endParaRPr sz="2400" dirty="0"/>
           </a:p>
           <a:p>
             <a:pPr marL="914400" lvl="1" indent="-304800" algn="l" rtl="0">
@@ -9188,10 +9226,10 @@
               <a:buChar char="○"/>
             </a:pPr>
             <a:r>
-              <a:rPr lang="en-CA" dirty="0"/>
+              <a:rPr lang="en-CA" sz="2400" dirty="0"/>
               <a:t>Extremely rare variants </a:t>
             </a:r>
-            <a:endParaRPr dirty="0"/>
+            <a:endParaRPr sz="2400" dirty="0"/>
           </a:p>
           <a:p>
             <a:pPr marL="914400" lvl="1" indent="-304800" algn="l" rtl="0">
@@ -9208,10 +9246,10 @@
               <a:buChar char="○"/>
             </a:pPr>
             <a:r>
-              <a:rPr lang="en-CA" dirty="0"/>
+              <a:rPr lang="en-CA" sz="2400" dirty="0"/>
               <a:t>Structural variants </a:t>
             </a:r>
-            <a:endParaRPr dirty="0"/>
+            <a:endParaRPr sz="2400" dirty="0"/>
           </a:p>
           <a:p>
             <a:pPr marL="914400" lvl="1" indent="-304800" algn="l" rtl="0">
@@ -9228,7 +9266,7 @@
               <a:buChar char="○"/>
             </a:pPr>
             <a:r>
-              <a:rPr lang="en-CA" dirty="0"/>
+              <a:rPr lang="en-CA" sz="2400" dirty="0"/>
               <a:t>Epigenetic modifications</a:t>
             </a:r>
           </a:p>
@@ -9247,7 +9285,7 @@
               <a:buChar char="○"/>
             </a:pPr>
             <a:r>
-              <a:rPr lang="en-CA" dirty="0"/>
+              <a:rPr lang="en-CA" sz="2400" dirty="0"/>
               <a:t>Gene-gene and gene-environment interactions</a:t>
             </a:r>
           </a:p>
@@ -9327,14 +9365,14 @@
           <p:nvPr>
             <p:extLst>
               <p:ext uri="{D42A27DB-BD31-4B8C-83A1-F6EECF244321}">
-                <p14:modId xmlns:p14="http://schemas.microsoft.com/office/powerpoint/2010/main" val="703985334"/>
+                <p14:modId xmlns:p14="http://schemas.microsoft.com/office/powerpoint/2010/main" val="3873336120"/>
               </p:ext>
             </p:extLst>
           </p:nvPr>
         </p:nvGraphicFramePr>
         <p:xfrm>
-          <a:off x="680950" y="1951300"/>
-          <a:ext cx="7782100" cy="3993550"/>
+          <a:off x="680950" y="1331240"/>
+          <a:ext cx="7782100" cy="4974276"/>
         </p:xfrm>
         <a:graphic>
           <a:graphicData uri="http://schemas.openxmlformats.org/drawingml/2006/table">
@@ -9377,7 +9415,7 @@
                         <a:buNone/>
                       </a:pPr>
                       <a:r>
-                        <a:rPr lang="en-CA" sz="1800" b="1" dirty="0">
+                        <a:rPr lang="en-CA" sz="2400" b="1" dirty="0">
                           <a:solidFill>
                             <a:schemeClr val="dk1"/>
                           </a:solidFill>
@@ -9388,7 +9426,7 @@
                         </a:rPr>
                         <a:t>Whole-genome sequencing</a:t>
                       </a:r>
-                      <a:endParaRPr sz="1800" b="1" dirty="0"/>
+                      <a:endParaRPr sz="2400" b="1" dirty="0"/>
                     </a:p>
                   </a:txBody>
                   <a:tcPr marL="91425" marR="91425" marT="91425" marB="91425">
@@ -9448,12 +9486,12 @@
                         <a:buNone/>
                       </a:pPr>
                       <a:r>
-                        <a:rPr lang="en-CA" sz="1800" b="1" dirty="0">
+                        <a:rPr lang="en-CA" sz="2400" b="1" dirty="0">
                           <a:latin typeface="Helvetica Neue" panose="020B0604020202020204"/>
                         </a:rPr>
                         <a:t>Genotyping</a:t>
                       </a:r>
-                      <a:endParaRPr sz="1800" b="1" dirty="0">
+                      <a:endParaRPr sz="2400" b="1" dirty="0">
                         <a:latin typeface="Helvetica Neue" panose="020B0604020202020204"/>
                       </a:endParaRPr>
                     </a:p>
@@ -9530,7 +9568,7 @@
                         <a:buChar char="●"/>
                       </a:pPr>
                       <a:r>
-                        <a:rPr lang="en-CA" sz="1800" dirty="0">
+                        <a:rPr lang="en-CA" sz="2400" dirty="0">
                           <a:solidFill>
                             <a:schemeClr val="dk1"/>
                           </a:solidFill>
@@ -9541,7 +9579,7 @@
                         </a:rPr>
                         <a:t>DNA is fragmented, sequenced, and aligned</a:t>
                       </a:r>
-                      <a:endParaRPr sz="1800" dirty="0">
+                      <a:endParaRPr sz="2400" dirty="0">
                         <a:solidFill>
                           <a:schemeClr val="dk1"/>
                         </a:solidFill>
@@ -9570,7 +9608,7 @@
                         <a:buChar char="●"/>
                       </a:pPr>
                       <a:r>
-                        <a:rPr lang="en-CA" sz="1800" dirty="0">
+                        <a:rPr lang="en-CA" sz="2400" dirty="0">
                           <a:solidFill>
                             <a:schemeClr val="dk1"/>
                           </a:solidFill>
@@ -9581,7 +9619,7 @@
                         </a:rPr>
                         <a:t>Annotate aligned reads to identify SNPs</a:t>
                       </a:r>
-                      <a:endParaRPr sz="1800" dirty="0">
+                      <a:endParaRPr sz="2400" dirty="0">
                         <a:solidFill>
                           <a:schemeClr val="dk1"/>
                         </a:solidFill>
@@ -9653,7 +9691,7 @@
                         <a:buChar char="●"/>
                       </a:pPr>
                       <a:r>
-                        <a:rPr lang="en-CA" sz="1800" dirty="0">
+                        <a:rPr lang="en-CA" sz="2400" dirty="0">
                           <a:solidFill>
                             <a:schemeClr val="dk1"/>
                           </a:solidFill>
@@ -9664,7 +9702,7 @@
                         </a:rPr>
                         <a:t>DNA hybridizes to microarray chips with probes to known SNPs</a:t>
                       </a:r>
-                      <a:endParaRPr sz="1800" dirty="0">
+                      <a:endParaRPr sz="2400" dirty="0">
                         <a:solidFill>
                           <a:schemeClr val="dk1"/>
                         </a:solidFill>
@@ -9692,7 +9730,7 @@
                         <a:buChar char="●"/>
                       </a:pPr>
                       <a:r>
-                        <a:rPr lang="en-CA" sz="1800" dirty="0">
+                        <a:rPr lang="en-CA" sz="2400" dirty="0">
                           <a:solidFill>
                             <a:schemeClr val="dk1"/>
                           </a:solidFill>
@@ -9703,7 +9741,7 @@
                         </a:rPr>
                         <a:t>When DNA is hybridized (binds to probe), it generates a fluorescent signal</a:t>
                       </a:r>
-                      <a:endParaRPr sz="1800" dirty="0">
+                      <a:endParaRPr sz="2400" dirty="0">
                         <a:solidFill>
                           <a:schemeClr val="dk1"/>
                         </a:solidFill>
@@ -9731,7 +9769,7 @@
                         <a:buChar char="●"/>
                       </a:pPr>
                       <a:r>
-                        <a:rPr lang="en-CA" sz="1800" dirty="0">
+                        <a:rPr lang="en-CA" sz="2400" dirty="0">
                           <a:solidFill>
                             <a:schemeClr val="dk1"/>
                           </a:solidFill>
@@ -9742,7 +9780,7 @@
                         </a:rPr>
                         <a:t>The intensity of the signals is processed</a:t>
                       </a:r>
-                      <a:endParaRPr sz="1800" dirty="0">
+                      <a:endParaRPr sz="2400" dirty="0">
                         <a:solidFill>
                           <a:schemeClr val="dk1"/>
                         </a:solidFill>
@@ -9770,7 +9808,7 @@
                         <a:buChar char="●"/>
                       </a:pPr>
                       <a:r>
-                        <a:rPr lang="en-CA" sz="1800" dirty="0">
+                        <a:rPr lang="en-CA" sz="2400" dirty="0">
                           <a:solidFill>
                             <a:schemeClr val="dk1"/>
                           </a:solidFill>
@@ -9781,7 +9819,7 @@
                         </a:rPr>
                         <a:t>Variants are annotated against reference genome</a:t>
                       </a:r>
-                      <a:endParaRPr dirty="0"/>
+                      <a:endParaRPr sz="2400" dirty="0"/>
                     </a:p>
                   </a:txBody>
                   <a:tcPr marL="91425" marR="91425" marT="91425" marB="91425">
@@ -9912,7 +9950,7 @@
         </p:nvSpPr>
         <p:spPr>
           <a:xfrm>
-            <a:off x="519343" y="1650354"/>
+            <a:off x="519343" y="1230300"/>
             <a:ext cx="7995900" cy="4397400"/>
           </a:xfrm>
           <a:prstGeom prst="rect">
@@ -9936,7 +9974,7 @@
               <a:buChar char="●"/>
             </a:pPr>
             <a:r>
-              <a:rPr lang="en-CA" dirty="0"/>
+              <a:rPr lang="en-CA" sz="2400" dirty="0"/>
               <a:t>Goal: test the effect of genetic variants on a trait/disease</a:t>
             </a:r>
           </a:p>
@@ -9952,8 +9990,8 @@
               <a:buChar char="●"/>
             </a:pPr>
             <a:r>
-              <a:rPr lang="en-CA" dirty="0"/>
-              <a:t>Continuous traits: linear regression</a:t>
+              <a:rPr lang="en-CA" sz="2400" dirty="0"/>
+              <a:t>Quantitative/Continuous traits: linear regression</a:t>
             </a:r>
           </a:p>
           <a:p>
@@ -9968,34 +10006,9 @@
               <a:buChar char="●"/>
             </a:pPr>
             <a:r>
-              <a:rPr lang="en-CA" dirty="0"/>
+              <a:rPr lang="en-CA" sz="2400" dirty="0"/>
               <a:t>Binary traits: logistic regression</a:t>
             </a:r>
-          </a:p>
-          <a:p>
-            <a:pPr marL="114300" lvl="0" indent="0" algn="l" rtl="0">
-              <a:spcBef>
-                <a:spcPts val="998"/>
-              </a:spcBef>
-              <a:spcAft>
-                <a:spcPts val="0"/>
-              </a:spcAft>
-              <a:buSzPts val="1800"/>
-              <a:buNone/>
-            </a:pPr>
-            <a:endParaRPr dirty="0"/>
-          </a:p>
-          <a:p>
-            <a:pPr marL="0" lvl="0" indent="0" algn="l" rtl="0">
-              <a:spcBef>
-                <a:spcPts val="1000"/>
-              </a:spcBef>
-              <a:spcAft>
-                <a:spcPts val="1000"/>
-              </a:spcAft>
-              <a:buNone/>
-            </a:pPr>
-            <a:endParaRPr dirty="0"/>
           </a:p>
         </p:txBody>
       </p:sp>
@@ -10345,7 +10358,7 @@
               <a:buChar char="●"/>
             </a:pPr>
             <a:r>
-              <a:rPr lang="en-CA" dirty="0"/>
+              <a:rPr lang="en-CA" sz="2400" dirty="0"/>
               <a:t>P &lt; 0.05 cannot be used (multiple testing burden)</a:t>
             </a:r>
           </a:p>
@@ -10360,7 +10373,7 @@
               <a:buSzPts val="1800"/>
               <a:buNone/>
             </a:pPr>
-            <a:endParaRPr lang="en-CA" dirty="0"/>
+            <a:endParaRPr lang="en-CA" sz="2400" dirty="0"/>
           </a:p>
           <a:p>
             <a:pPr marL="457200" lvl="0" indent="-342900" algn="l" rtl="0">
@@ -10374,15 +10387,15 @@
               <a:buChar char="●"/>
             </a:pPr>
             <a:r>
-              <a:rPr lang="en-CA" dirty="0"/>
+              <a:rPr lang="en-CA" sz="2400" dirty="0"/>
               <a:t>Adjust for number of independent </a:t>
             </a:r>
             <a:r>
-              <a:rPr lang="en-CA" b="1" dirty="0"/>
+              <a:rPr lang="en-CA" sz="2400" b="1" dirty="0"/>
               <a:t>LD blocks </a:t>
             </a:r>
             <a:r>
-              <a:rPr lang="en-CA" dirty="0"/>
+              <a:rPr lang="en-CA" sz="2400" dirty="0"/>
               <a:t>across the entire genome</a:t>
             </a:r>
           </a:p>
@@ -10397,7 +10410,7 @@
               <a:buSzPts val="1800"/>
               <a:buChar char="●"/>
             </a:pPr>
-            <a:endParaRPr lang="en-CA" dirty="0"/>
+            <a:endParaRPr lang="en-CA" sz="2400" dirty="0"/>
           </a:p>
           <a:p>
             <a:pPr marL="457200" lvl="0" indent="-342900" algn="l" rtl="0">
@@ -10411,15 +10424,15 @@
               <a:buChar char="●"/>
             </a:pPr>
             <a:r>
-              <a:rPr lang="en-CA" dirty="0"/>
+              <a:rPr lang="en-CA" sz="2400" dirty="0"/>
               <a:t>There are roughly 1 million blocks of SNPs (</a:t>
             </a:r>
             <a:r>
-              <a:rPr lang="en-CA" b="1" dirty="0"/>
+              <a:rPr lang="en-CA" sz="2400" b="1" dirty="0"/>
               <a:t>LD blocks</a:t>
             </a:r>
             <a:r>
-              <a:rPr lang="en-CA" dirty="0"/>
+              <a:rPr lang="en-CA" sz="2400" dirty="0"/>
               <a:t>) independent of each other</a:t>
             </a:r>
           </a:p>
@@ -10434,7 +10447,7 @@
               <a:buSzPts val="1800"/>
               <a:buChar char="●"/>
             </a:pPr>
-            <a:endParaRPr lang="en-CA" dirty="0"/>
+            <a:endParaRPr lang="en-CA" sz="2400" dirty="0"/>
           </a:p>
           <a:p>
             <a:pPr marL="457200" lvl="0" indent="-342900" algn="l" rtl="0">
@@ -10448,11 +10461,11 @@
               <a:buChar char="●"/>
             </a:pPr>
             <a:r>
-              <a:rPr lang="en-CA" dirty="0"/>
+              <a:rPr lang="en-CA" sz="2400" dirty="0"/>
               <a:t>Apply Bonferroni P-value correction: P = 0.05 / 1,000,000 = </a:t>
             </a:r>
             <a:r>
-              <a:rPr lang="en-CA" b="1" dirty="0"/>
+              <a:rPr lang="en-CA" sz="2400" b="1" dirty="0"/>
               <a:t>5x10e-8</a:t>
             </a:r>
           </a:p>
@@ -11213,7 +11226,7 @@
         </p:nvSpPr>
         <p:spPr>
           <a:xfrm>
-            <a:off x="519343" y="1650354"/>
+            <a:off x="519343" y="1230300"/>
             <a:ext cx="7995900" cy="4397400"/>
           </a:xfrm>
           <a:prstGeom prst="rect">
@@ -11237,7 +11250,7 @@
               <a:buChar char="●"/>
             </a:pPr>
             <a:r>
-              <a:rPr lang="en-CA" dirty="0"/>
+              <a:rPr lang="en-CA" sz="2400" dirty="0"/>
               <a:t>Pitfall: raw summary statistics association cannot be used directly </a:t>
             </a:r>
           </a:p>
@@ -11252,7 +11265,7 @@
               <a:buSzPts val="1800"/>
               <a:buChar char="●"/>
             </a:pPr>
-            <a:endParaRPr lang="en-CA" dirty="0"/>
+            <a:endParaRPr lang="en-CA" sz="2400" dirty="0"/>
           </a:p>
           <a:p>
             <a:pPr marL="457200" lvl="0" indent="-342900" algn="l" rtl="0">
@@ -11266,7 +11279,7 @@
               <a:buChar char="●"/>
             </a:pPr>
             <a:r>
-              <a:rPr lang="en-CA" dirty="0"/>
+              <a:rPr lang="en-CA" sz="2400" dirty="0"/>
               <a:t>True risk variant will “tag” other variants through LD</a:t>
             </a:r>
           </a:p>
@@ -11281,7 +11294,7 @@
               <a:buSzPts val="1800"/>
               <a:buChar char="●"/>
             </a:pPr>
-            <a:endParaRPr lang="en-CA" dirty="0"/>
+            <a:endParaRPr lang="en-CA" sz="2400" dirty="0"/>
           </a:p>
         </p:txBody>
       </p:sp>
@@ -11465,8 +11478,8 @@
         </p:nvSpPr>
         <p:spPr>
           <a:xfrm>
-            <a:off x="519343" y="1569531"/>
-            <a:ext cx="7995900" cy="4397400"/>
+            <a:off x="519343" y="1230300"/>
+            <a:ext cx="8481782" cy="4397400"/>
           </a:xfrm>
           <a:prstGeom prst="rect">
             <a:avLst/>
@@ -11489,22 +11502,10 @@
               <a:buChar char="●"/>
             </a:pPr>
             <a:r>
-              <a:rPr lang="en-CA" dirty="0"/>
+              <a:rPr lang="en-CA" sz="2400" dirty="0"/>
               <a:t>Allele frequencies can vary between different ancestries</a:t>
             </a:r>
-          </a:p>
-          <a:p>
-            <a:pPr marL="114300" lvl="0" indent="0" algn="l" rtl="0">
-              <a:spcBef>
-                <a:spcPts val="998"/>
-              </a:spcBef>
-              <a:spcAft>
-                <a:spcPts val="0"/>
-              </a:spcAft>
-              <a:buSzPts val="1800"/>
-              <a:buNone/>
-            </a:pPr>
-            <a:endParaRPr dirty="0"/>
+            <a:endParaRPr sz="2400" dirty="0"/>
           </a:p>
           <a:p>
             <a:pPr marL="457200" lvl="0" indent="-342900" algn="l" rtl="0">
@@ -11517,11 +11518,24 @@
               <a:buSzPts val="1800"/>
               <a:buChar char="●"/>
             </a:pPr>
-            <a:r>
-              <a:rPr lang="en-CA" dirty="0"/>
+            <a:endParaRPr lang="en-CA" sz="2400" dirty="0"/>
+          </a:p>
+          <a:p>
+            <a:pPr marL="457200" lvl="0" indent="-342900" algn="l" rtl="0">
+              <a:spcBef>
+                <a:spcPts val="0"/>
+              </a:spcBef>
+              <a:spcAft>
+                <a:spcPts val="0"/>
+              </a:spcAft>
+              <a:buSzPts val="1800"/>
+              <a:buChar char="●"/>
+            </a:pPr>
+            <a:r>
+              <a:rPr lang="en-CA" sz="2400" dirty="0"/>
               <a:t>Migrations, genetic drift, selection pressures:</a:t>
             </a:r>
-            <a:endParaRPr dirty="0"/>
+            <a:endParaRPr sz="2400" dirty="0"/>
           </a:p>
           <a:p>
             <a:pPr marL="914400" lvl="1" indent="-304800" algn="l" rtl="0">
@@ -11535,10 +11549,10 @@
               <a:buChar char="○"/>
             </a:pPr>
             <a:r>
-              <a:rPr lang="en-CA" dirty="0"/>
+              <a:rPr lang="en-CA" sz="2400" dirty="0"/>
               <a:t>Differences in allele frequencies</a:t>
             </a:r>
-            <a:endParaRPr dirty="0"/>
+            <a:endParaRPr sz="2400" dirty="0"/>
           </a:p>
           <a:p>
             <a:pPr marL="914400" lvl="1" indent="-304800" algn="l" rtl="0">
@@ -11552,59 +11566,9 @@
               <a:buChar char="○"/>
             </a:pPr>
             <a:r>
-              <a:rPr lang="en-CA" dirty="0"/>
+              <a:rPr lang="en-CA" sz="2400" dirty="0"/>
               <a:t>Differences in how genetic variants are inherited together (LD)</a:t>
             </a:r>
-          </a:p>
-          <a:p>
-            <a:pPr marL="609600" lvl="1" indent="0" algn="l" rtl="0">
-              <a:spcBef>
-                <a:spcPts val="0"/>
-              </a:spcBef>
-              <a:spcAft>
-                <a:spcPts val="0"/>
-              </a:spcAft>
-              <a:buSzPts val="1200"/>
-              <a:buNone/>
-            </a:pPr>
-            <a:endParaRPr lang="en-CA" dirty="0"/>
-          </a:p>
-          <a:p>
-            <a:pPr marL="609600" lvl="1" indent="0" algn="l" rtl="0">
-              <a:spcBef>
-                <a:spcPts val="0"/>
-              </a:spcBef>
-              <a:spcAft>
-                <a:spcPts val="0"/>
-              </a:spcAft>
-              <a:buSzPts val="1200"/>
-              <a:buNone/>
-            </a:pPr>
-            <a:endParaRPr dirty="0"/>
-          </a:p>
-          <a:p>
-            <a:pPr marL="457200" lvl="0" indent="0" algn="l" rtl="0">
-              <a:spcBef>
-                <a:spcPts val="1000"/>
-              </a:spcBef>
-              <a:spcAft>
-                <a:spcPts val="0"/>
-              </a:spcAft>
-              <a:buNone/>
-            </a:pPr>
-            <a:endParaRPr dirty="0"/>
-          </a:p>
-          <a:p>
-            <a:pPr marL="914400" lvl="0" indent="0" algn="l" rtl="0">
-              <a:spcBef>
-                <a:spcPts val="1000"/>
-              </a:spcBef>
-              <a:spcAft>
-                <a:spcPts val="1000"/>
-              </a:spcAft>
-              <a:buNone/>
-            </a:pPr>
-            <a:endParaRPr dirty="0"/>
           </a:p>
         </p:txBody>
       </p:sp>
@@ -11630,7 +11594,7 @@
         </p:blipFill>
         <p:spPr>
           <a:xfrm>
-            <a:off x="2285933" y="3177304"/>
+            <a:off x="2537520" y="3395220"/>
             <a:ext cx="3630126" cy="3088365"/>
           </a:xfrm>
           <a:prstGeom prst="rect">
@@ -11708,6 +11672,267 @@
           <a:chExt cx="0" cy="0"/>
         </a:xfrm>
       </p:grpSpPr>
+      <p:sp>
+        <p:nvSpPr>
+          <p:cNvPr id="4" name="Content Placeholder 3">
+            <a:extLst>
+              <a:ext uri="{FF2B5EF4-FFF2-40B4-BE49-F238E27FC236}">
+                <a16:creationId xmlns:a16="http://schemas.microsoft.com/office/drawing/2014/main" id="{8AE12D43-9137-DB7C-570B-E48AB2308897}"/>
+              </a:ext>
+            </a:extLst>
+          </p:cNvPr>
+          <p:cNvSpPr>
+            <a:spLocks noGrp="1"/>
+          </p:cNvSpPr>
+          <p:nvPr>
+            <p:ph sz="half" idx="2"/>
+          </p:nvPr>
+        </p:nvSpPr>
+        <p:spPr>
+          <a:xfrm>
+            <a:off x="924887" y="5357337"/>
+            <a:ext cx="3224152" cy="1266357"/>
+          </a:xfrm>
+        </p:spPr>
+        <p:txBody>
+          <a:bodyPr>
+            <a:normAutofit/>
+          </a:bodyPr>
+          <a:lstStyle/>
+          <a:p>
+            <a:pPr marL="0" indent="0">
+              <a:buNone/>
+            </a:pPr>
+            <a:r>
+              <a:rPr lang="en-CA" sz="1800" dirty="0"/>
+              <a:t>Location: 680 </a:t>
+            </a:r>
+            <a:r>
+              <a:rPr lang="en-US" altLang="zh-CN" sz="1800" dirty="0"/>
+              <a:t>Rue Sherbrooke</a:t>
+            </a:r>
+            <a:r>
+              <a:rPr lang="en-CA" sz="1800" dirty="0"/>
+              <a:t>, Montreal, Quebec</a:t>
+            </a:r>
+          </a:p>
+        </p:txBody>
+      </p:sp>
+      <p:sp>
+        <p:nvSpPr>
+          <p:cNvPr id="8" name="TextBox 7">
+            <a:extLst>
+              <a:ext uri="{FF2B5EF4-FFF2-40B4-BE49-F238E27FC236}">
+                <a16:creationId xmlns:a16="http://schemas.microsoft.com/office/drawing/2014/main" id="{2A92A9C4-6F5B-9A18-012E-5626D25E3582}"/>
+              </a:ext>
+            </a:extLst>
+          </p:cNvPr>
+          <p:cNvSpPr txBox="1"/>
+          <p:nvPr/>
+        </p:nvSpPr>
+        <p:spPr>
+          <a:xfrm>
+            <a:off x="1438517" y="1344109"/>
+            <a:ext cx="6283877" cy="923330"/>
+          </a:xfrm>
+          <a:prstGeom prst="rect">
+            <a:avLst/>
+          </a:prstGeom>
+          <a:noFill/>
+        </p:spPr>
+        <p:txBody>
+          <a:bodyPr wrap="square" lIns="91440" tIns="45720" rIns="91440" bIns="45720" rtlCol="0" anchor="t">
+            <a:spAutoFit/>
+          </a:bodyPr>
+          <a:lstStyle/>
+          <a:p>
+            <a:pPr algn="ctr"/>
+            <a:r>
+              <a:rPr lang="en-CA" sz="1800" u="sng">
+                <a:latin typeface="Helvetica" pitchFamily="2" charset="0"/>
+              </a:rPr>
+              <a:t>Mission statement:</a:t>
+            </a:r>
+            <a:r>
+              <a:rPr lang="en-CA" sz="1800">
+                <a:latin typeface="Helvetica" pitchFamily="2" charset="0"/>
+              </a:rPr>
+              <a:t> d</a:t>
+            </a:r>
+            <a:r>
+              <a:rPr lang="en-CA" sz="1800" b="0" i="0">
+                <a:solidFill>
+                  <a:srgbClr val="000000"/>
+                </a:solidFill>
+                <a:effectLst/>
+                <a:latin typeface="Helvetica" pitchFamily="2" charset="0"/>
+                <a:cs typeface="Calibri"/>
+              </a:rPr>
+              <a:t>eliver quality workshops designed to help biomedical researchers develop the skills they need to succeed.</a:t>
+            </a:r>
+            <a:endParaRPr lang="en-CA" sz="1800">
+              <a:latin typeface="Helvetica" pitchFamily="2" charset="0"/>
+              <a:cs typeface="Calibri"/>
+            </a:endParaRPr>
+          </a:p>
+        </p:txBody>
+      </p:sp>
+      <p:pic>
+        <p:nvPicPr>
+          <p:cNvPr id="10" name="Picture 9" descr="A logo with a letter m&#10;&#10;Description automatically generated">
+            <a:extLst>
+              <a:ext uri="{FF2B5EF4-FFF2-40B4-BE49-F238E27FC236}">
+                <a16:creationId xmlns:a16="http://schemas.microsoft.com/office/drawing/2014/main" id="{E494228A-9E5D-1800-FDEC-760556611BD3}"/>
+              </a:ext>
+            </a:extLst>
+          </p:cNvPr>
+          <p:cNvPicPr>
+            <a:picLocks noChangeAspect="1"/>
+          </p:cNvPicPr>
+          <p:nvPr/>
+        </p:nvPicPr>
+        <p:blipFill>
+          <a:blip r:embed="rId3"/>
+          <a:stretch>
+            <a:fillRect/>
+          </a:stretch>
+        </p:blipFill>
+        <p:spPr>
+          <a:xfrm>
+            <a:off x="2574183" y="123976"/>
+            <a:ext cx="3995634" cy="964279"/>
+          </a:xfrm>
+          <a:prstGeom prst="rect">
+            <a:avLst/>
+          </a:prstGeom>
+        </p:spPr>
+      </p:pic>
+      <p:sp>
+        <p:nvSpPr>
+          <p:cNvPr id="13" name="TextBox 12">
+            <a:extLst>
+              <a:ext uri="{FF2B5EF4-FFF2-40B4-BE49-F238E27FC236}">
+                <a16:creationId xmlns:a16="http://schemas.microsoft.com/office/drawing/2014/main" id="{174C1E59-2F37-F73C-4DFA-8971D19A54AE}"/>
+              </a:ext>
+            </a:extLst>
+          </p:cNvPr>
+          <p:cNvSpPr txBox="1"/>
+          <p:nvPr/>
+        </p:nvSpPr>
+        <p:spPr>
+          <a:xfrm>
+            <a:off x="4373913" y="5288330"/>
+            <a:ext cx="4632294" cy="646331"/>
+          </a:xfrm>
+          <a:prstGeom prst="rect">
+            <a:avLst/>
+          </a:prstGeom>
+          <a:noFill/>
+        </p:spPr>
+        <p:txBody>
+          <a:bodyPr wrap="square" lIns="91440" tIns="45720" rIns="91440" bIns="45720" rtlCol="0" anchor="t">
+            <a:spAutoFit/>
+          </a:bodyPr>
+          <a:lstStyle/>
+          <a:p>
+            <a:pPr algn="ctr"/>
+            <a:r>
+              <a:rPr lang="en-CA" sz="1800"/>
+              <a:t>Scan the QR code to sign up </a:t>
+            </a:r>
+          </a:p>
+          <a:p>
+            <a:pPr algn="ctr"/>
+            <a:r>
+              <a:rPr lang="en-CA" sz="1800"/>
+              <a:t>for our </a:t>
+            </a:r>
+            <a:r>
+              <a:rPr lang="en-CA" sz="1800" b="1"/>
+              <a:t>mailing list</a:t>
+            </a:r>
+            <a:endParaRPr lang="en-CA" sz="1800"/>
+          </a:p>
+        </p:txBody>
+      </p:sp>
+      <p:sp>
+        <p:nvSpPr>
+          <p:cNvPr id="3" name="TextBox 2">
+            <a:extLst>
+              <a:ext uri="{FF2B5EF4-FFF2-40B4-BE49-F238E27FC236}">
+                <a16:creationId xmlns:a16="http://schemas.microsoft.com/office/drawing/2014/main" id="{8E0D0C58-4777-B836-81EE-F027A53CFFAF}"/>
+              </a:ext>
+            </a:extLst>
+          </p:cNvPr>
+          <p:cNvSpPr txBox="1"/>
+          <p:nvPr/>
+        </p:nvSpPr>
+        <p:spPr>
+          <a:xfrm>
+            <a:off x="398115" y="6254362"/>
+            <a:ext cx="4596848" cy="369332"/>
+          </a:xfrm>
+          <a:prstGeom prst="rect">
+            <a:avLst/>
+          </a:prstGeom>
+          <a:noFill/>
+        </p:spPr>
+        <p:txBody>
+          <a:bodyPr wrap="square">
+            <a:spAutoFit/>
+          </a:bodyPr>
+          <a:lstStyle/>
+          <a:p>
+            <a:pPr marL="0" indent="0">
+              <a:buNone/>
+            </a:pPr>
+            <a:r>
+              <a:rPr lang="en-CA" sz="1800" dirty="0"/>
+              <a:t>Contact: </a:t>
+            </a:r>
+            <a:r>
+              <a:rPr lang="en-CA" sz="1800" dirty="0">
+                <a:hlinkClick r:id="rId4"/>
+              </a:rPr>
+              <a:t>workshop-micm@mcgill.ca</a:t>
+            </a:r>
+            <a:r>
+              <a:rPr lang="en-CA" sz="1800" dirty="0"/>
+              <a:t> </a:t>
+            </a:r>
+          </a:p>
+        </p:txBody>
+      </p:sp>
+      <p:pic>
+        <p:nvPicPr>
+          <p:cNvPr id="5" name="Picture 4">
+            <a:extLst>
+              <a:ext uri="{FF2B5EF4-FFF2-40B4-BE49-F238E27FC236}">
+                <a16:creationId xmlns:a16="http://schemas.microsoft.com/office/drawing/2014/main" id="{B5B72818-3611-8941-CEDA-83D82BFF19C3}"/>
+              </a:ext>
+            </a:extLst>
+          </p:cNvPr>
+          <p:cNvPicPr>
+            <a:picLocks noChangeAspect="1"/>
+          </p:cNvPicPr>
+          <p:nvPr/>
+        </p:nvPicPr>
+        <p:blipFill>
+          <a:blip r:embed="rId5"/>
+          <a:stretch>
+            <a:fillRect/>
+          </a:stretch>
+        </p:blipFill>
+        <p:spPr>
+          <a:xfrm>
+            <a:off x="1125982" y="2855720"/>
+            <a:ext cx="2404909" cy="2080908"/>
+          </a:xfrm>
+          <a:prstGeom prst="rect">
+            <a:avLst/>
+          </a:prstGeom>
+        </p:spPr>
+      </p:pic>
       <p:pic>
         <p:nvPicPr>
           <p:cNvPr id="2" name="Google Shape;66;p12" descr="A qr code with black squares&#10;&#10;Description automatically generated">
@@ -11721,7 +11946,7 @@
           <p:nvPr/>
         </p:nvPicPr>
         <p:blipFill rotWithShape="1">
-          <a:blip r:embed="rId3">
+          <a:blip r:embed="rId6">
             <a:alphaModFix/>
           </a:blip>
           <a:srcRect/>
@@ -11729,7 +11954,7 @@
         </p:blipFill>
         <p:spPr>
           <a:xfrm>
-            <a:off x="562507" y="2440109"/>
+            <a:off x="5518580" y="2794267"/>
             <a:ext cx="2203814" cy="2203814"/>
           </a:xfrm>
           <a:prstGeom prst="rect">
@@ -11744,7 +11969,7 @@
     </p:spTree>
     <p:extLst>
       <p:ext uri="{BB962C8B-B14F-4D97-AF65-F5344CB8AC3E}">
-        <p14:creationId xmlns:p14="http://schemas.microsoft.com/office/powerpoint/2010/main" val="3133242724"/>
+        <p14:creationId xmlns:p14="http://schemas.microsoft.com/office/powerpoint/2010/main" val="1324269546"/>
       </p:ext>
     </p:extLst>
   </p:cSld>
@@ -12204,7 +12429,7 @@
         </p:nvSpPr>
         <p:spPr>
           <a:xfrm>
-            <a:off x="519343" y="1650354"/>
+            <a:off x="574050" y="1078854"/>
             <a:ext cx="7995900" cy="4397400"/>
           </a:xfrm>
           <a:prstGeom prst="rect">
@@ -12227,10 +12452,10 @@
               <a:buNone/>
             </a:pPr>
             <a:r>
-              <a:rPr lang="en-CA" b="1"/>
+              <a:rPr lang="en-CA" sz="2400" b="1" dirty="0"/>
               <a:t>Where can I search for GWAS summary statistics?</a:t>
             </a:r>
-            <a:endParaRPr b="1"/>
+            <a:endParaRPr sz="2400" b="1" dirty="0"/>
           </a:p>
           <a:p>
             <a:pPr marL="0" lvl="0" indent="0" algn="l" rtl="0">
@@ -12243,11 +12468,11 @@
               <a:buNone/>
             </a:pPr>
             <a:r>
-              <a:rPr lang="en-CA"/>
+              <a:rPr lang="en-CA" sz="2400" dirty="0"/>
               <a:t>Visit </a:t>
             </a:r>
             <a:r>
-              <a:rPr lang="en-CA" u="sng">
+              <a:rPr lang="en-CA" sz="2400" u="sng" dirty="0">
                 <a:solidFill>
                   <a:schemeClr val="hlink"/>
                 </a:solidFill>
@@ -12256,10 +12481,10 @@
               <a:t>https://www.ebi.ac.uk/gwas/</a:t>
             </a:r>
             <a:r>
-              <a:rPr lang="en-CA"/>
+              <a:rPr lang="en-CA" sz="2400" dirty="0"/>
               <a:t> to look through GWAS summary statistics.</a:t>
             </a:r>
-            <a:endParaRPr/>
+            <a:endParaRPr sz="2400" dirty="0"/>
           </a:p>
         </p:txBody>
       </p:sp>
@@ -12279,7 +12504,7 @@
         </p:blipFill>
         <p:spPr>
           <a:xfrm>
-            <a:off x="519362" y="2685775"/>
+            <a:off x="1318137" y="2625393"/>
             <a:ext cx="6507725" cy="3693800"/>
           </a:xfrm>
           <a:prstGeom prst="rect">
@@ -12394,7 +12619,7 @@
               <a:buAutoNum type="arabicPeriod"/>
             </a:pPr>
             <a:r>
-              <a:rPr lang="en-CA" dirty="0"/>
+              <a:rPr lang="en-CA" sz="2400" dirty="0"/>
               <a:t>Genome-wide association studies identify SNPs that are associated to traits.</a:t>
             </a:r>
           </a:p>
@@ -12409,7 +12634,7 @@
               <a:buSzPts val="1800"/>
               <a:buAutoNum type="arabicPeriod"/>
             </a:pPr>
-            <a:endParaRPr lang="en-CA" dirty="0"/>
+            <a:endParaRPr lang="en-CA" sz="2400" dirty="0"/>
           </a:p>
           <a:p>
             <a:pPr marL="457200" lvl="0" indent="-342900" algn="l" rtl="0">
@@ -12423,7 +12648,7 @@
               <a:buAutoNum type="arabicPeriod"/>
             </a:pPr>
             <a:r>
-              <a:rPr lang="en-CA" dirty="0"/>
+              <a:rPr lang="en-CA" sz="2400" dirty="0"/>
               <a:t>LD prevents direct use of GWAS for risk stratification and inference of causal gene</a:t>
             </a:r>
           </a:p>
@@ -12438,7 +12663,7 @@
               <a:buSzPts val="1800"/>
               <a:buAutoNum type="arabicPeriod"/>
             </a:pPr>
-            <a:endParaRPr lang="en-CA" dirty="0"/>
+            <a:endParaRPr lang="en-CA" sz="2400" dirty="0"/>
           </a:p>
           <a:p>
             <a:pPr marL="457200" lvl="0" indent="-342900" algn="l" rtl="0">
@@ -12452,7 +12677,7 @@
               <a:buAutoNum type="arabicPeriod"/>
             </a:pPr>
             <a:r>
-              <a:rPr lang="en-CA" dirty="0"/>
+              <a:rPr lang="en-CA" sz="2400" dirty="0"/>
               <a:t>GWAS performed in European populations may not generalize to other ancestries.</a:t>
             </a:r>
           </a:p>
@@ -12467,7 +12692,7 @@
               <a:buSzPts val="1800"/>
               <a:buAutoNum type="arabicPeriod"/>
             </a:pPr>
-            <a:endParaRPr dirty="0"/>
+            <a:endParaRPr sz="2400" dirty="0"/>
           </a:p>
           <a:p>
             <a:pPr marL="457200" lvl="0" indent="-342900" algn="l" rtl="0">
@@ -12481,10 +12706,10 @@
               <a:buAutoNum type="arabicPeriod"/>
             </a:pPr>
             <a:r>
-              <a:rPr lang="en-CA" dirty="0"/>
+              <a:rPr lang="en-CA" sz="2400" dirty="0"/>
               <a:t>Open sources (like GWAS catalog) contain summary statistics for GWAS.</a:t>
             </a:r>
-            <a:endParaRPr dirty="0"/>
+            <a:endParaRPr sz="2400" dirty="0"/>
           </a:p>
         </p:txBody>
       </p:sp>
@@ -12633,10 +12858,10 @@
           <a:p>
             <a:pPr algn="ctr"/>
             <a:r>
-              <a:rPr lang="en-CA" altLang="zh-CN" dirty="0"/>
+              <a:rPr lang="en-CA" altLang="zh-CN" sz="2400" dirty="0"/>
               <a:t>Part 1. Genome-wide association studies (GWAS)</a:t>
             </a:r>
-            <a:endParaRPr lang="zh-CN" altLang="en-US" dirty="0"/>
+            <a:endParaRPr lang="zh-CN" altLang="en-US" sz="2400" dirty="0"/>
           </a:p>
         </p:txBody>
       </p:sp>
@@ -12694,10 +12919,10 @@
           <a:p>
             <a:pPr algn="ctr"/>
             <a:r>
-              <a:rPr lang="en-CA" altLang="zh-CN" dirty="0"/>
+              <a:rPr lang="en-CA" altLang="zh-CN" sz="2400" dirty="0"/>
               <a:t>Part 2. Polygenic risk scores (PRS)</a:t>
             </a:r>
-            <a:endParaRPr lang="zh-CN" altLang="en-US" dirty="0"/>
+            <a:endParaRPr lang="zh-CN" altLang="en-US" sz="2400" dirty="0"/>
           </a:p>
         </p:txBody>
       </p:sp>
@@ -12755,10 +12980,10 @@
           <a:p>
             <a:pPr algn="ctr"/>
             <a:r>
-              <a:rPr lang="en-CA" altLang="zh-CN" dirty="0"/>
+              <a:rPr lang="en-CA" altLang="zh-CN" sz="2400" dirty="0"/>
               <a:t>Part 3. Tutorial for PRS of coronary artery disease</a:t>
             </a:r>
-            <a:endParaRPr lang="zh-CN" altLang="en-US" dirty="0"/>
+            <a:endParaRPr lang="zh-CN" altLang="en-US" sz="2400" dirty="0"/>
           </a:p>
         </p:txBody>
       </p:sp>
@@ -13011,20 +13236,20 @@
         </p:nvSpPr>
         <p:spPr>
           <a:xfrm>
-            <a:off x="519343" y="1650354"/>
-            <a:ext cx="7995900" cy="4397400"/>
+            <a:off x="519343" y="1127438"/>
+            <a:ext cx="7995900" cy="2221181"/>
           </a:xfrm>
           <a:prstGeom prst="rect">
             <a:avLst/>
           </a:prstGeom>
         </p:spPr>
         <p:txBody>
-          <a:bodyPr spcFirstLastPara="1" wrap="square" lIns="91425" tIns="45700" rIns="91425" bIns="45700" anchor="t" anchorCtr="0">
+          <a:bodyPr spcFirstLastPara="1" wrap="square" lIns="91425" tIns="45700" rIns="91425" bIns="45700" anchor="ctr" anchorCtr="0">
             <a:normAutofit/>
           </a:bodyPr>
           <a:lstStyle/>
           <a:p>
-            <a:pPr marL="114300" lvl="0" indent="0" algn="l" rtl="0">
+            <a:pPr marL="114300" lvl="0" indent="0" algn="ctr" rtl="0">
               <a:spcBef>
                 <a:spcPts val="998"/>
               </a:spcBef>
@@ -13034,62 +13259,11 @@
               <a:buSzPts val="1800"/>
               <a:buNone/>
             </a:pPr>
-            <a:endParaRPr lang="en-CA" dirty="0"/>
-          </a:p>
-          <a:p>
-            <a:pPr marL="114300" lvl="0" indent="0" algn="l" rtl="0">
-              <a:spcBef>
-                <a:spcPts val="998"/>
-              </a:spcBef>
-              <a:spcAft>
-                <a:spcPts val="0"/>
-              </a:spcAft>
-              <a:buSzPts val="1800"/>
-              <a:buNone/>
-            </a:pPr>
-            <a:endParaRPr lang="en-CA" dirty="0"/>
-          </a:p>
-          <a:p>
-            <a:pPr marL="114300" lvl="0" indent="0" algn="l" rtl="0">
-              <a:spcBef>
-                <a:spcPts val="998"/>
-              </a:spcBef>
-              <a:spcAft>
-                <a:spcPts val="0"/>
-              </a:spcAft>
-              <a:buSzPts val="1800"/>
-              <a:buNone/>
-            </a:pPr>
-            <a:endParaRPr lang="en-CA" dirty="0"/>
-          </a:p>
-          <a:p>
-            <a:pPr marL="114300" lvl="0" indent="0" algn="ctr" rtl="0">
-              <a:spcBef>
-                <a:spcPts val="998"/>
-              </a:spcBef>
-              <a:spcAft>
-                <a:spcPts val="0"/>
-              </a:spcAft>
-              <a:buSzPts val="1800"/>
-              <a:buNone/>
-            </a:pPr>
-            <a:r>
-              <a:rPr lang="en-CA" sz="2000" b="1" dirty="0"/>
+            <a:r>
+              <a:rPr lang="en-CA" sz="2400" b="1" dirty="0"/>
               <a:t>Goal: early screening, stratification of high-risk individuals </a:t>
             </a:r>
-            <a:endParaRPr sz="2000" b="1" dirty="0"/>
-          </a:p>
-          <a:p>
-            <a:pPr marL="457200" lvl="0" indent="0" algn="l" rtl="0">
-              <a:spcBef>
-                <a:spcPts val="1000"/>
-              </a:spcBef>
-              <a:spcAft>
-                <a:spcPts val="1000"/>
-              </a:spcAft>
-              <a:buNone/>
-            </a:pPr>
-            <a:endParaRPr dirty="0"/>
+            <a:endParaRPr sz="2400" b="1" dirty="0"/>
           </a:p>
         </p:txBody>
       </p:sp>
@@ -13122,8 +13296,8 @@
         </p:blipFill>
         <p:spPr bwMode="auto">
           <a:xfrm>
-            <a:off x="2375210" y="4120829"/>
-            <a:ext cx="4047893" cy="2173634"/>
+            <a:off x="1784135" y="3171826"/>
+            <a:ext cx="5575729" cy="2994050"/>
           </a:xfrm>
           <a:prstGeom prst="rect">
             <a:avLst/>
@@ -13215,8 +13389,8 @@
         </p:nvSpPr>
         <p:spPr>
           <a:xfrm>
-            <a:off x="567275" y="2056375"/>
-            <a:ext cx="2228700" cy="2228700"/>
+            <a:off x="519343" y="1199274"/>
+            <a:ext cx="2537643" cy="2529763"/>
           </a:xfrm>
           <a:prstGeom prst="roundRect">
             <a:avLst>
@@ -13252,7 +13426,7 @@
               <a:buNone/>
             </a:pPr>
             <a:r>
-              <a:rPr lang="en-CA" b="1" u="sng" dirty="0">
+              <a:rPr lang="en-CA" sz="2400" b="1" u="sng" dirty="0">
                 <a:latin typeface="Helvetica Neue"/>
                 <a:ea typeface="Helvetica Neue"/>
                 <a:cs typeface="Helvetica Neue"/>
@@ -13260,7 +13434,7 @@
               </a:rPr>
               <a:t>Target data</a:t>
             </a:r>
-            <a:endParaRPr b="1" u="sng" dirty="0">
+            <a:endParaRPr sz="2400" b="1" u="sng" dirty="0">
               <a:latin typeface="Helvetica Neue"/>
               <a:ea typeface="Helvetica Neue"/>
               <a:cs typeface="Helvetica Neue"/>
@@ -13278,7 +13452,7 @@
               <a:buNone/>
             </a:pPr>
             <a:r>
-              <a:rPr lang="en-CA" b="1" dirty="0">
+              <a:rPr lang="en-CA" sz="2400" b="1" dirty="0">
                 <a:latin typeface="Helvetica Neue"/>
                 <a:ea typeface="Helvetica Neue"/>
                 <a:cs typeface="Helvetica Neue"/>
@@ -13286,7 +13460,7 @@
               </a:rPr>
               <a:t>Individual-level genotype </a:t>
             </a:r>
-            <a:endParaRPr dirty="0">
+            <a:endParaRPr sz="2400" dirty="0">
               <a:latin typeface="Helvetica Neue"/>
               <a:ea typeface="Helvetica Neue"/>
               <a:cs typeface="Helvetica Neue"/>
@@ -13303,8 +13477,8 @@
         </p:nvSpPr>
         <p:spPr>
           <a:xfrm>
-            <a:off x="3302825" y="2056375"/>
-            <a:ext cx="2228700" cy="2228700"/>
+            <a:off x="3254893" y="1199274"/>
+            <a:ext cx="2537643" cy="2529763"/>
           </a:xfrm>
           <a:prstGeom prst="roundRect">
             <a:avLst>
@@ -13340,7 +13514,7 @@
               <a:buNone/>
             </a:pPr>
             <a:r>
-              <a:rPr lang="en-CA" b="1" u="sng" dirty="0">
+              <a:rPr lang="en-CA" sz="2400" b="1" u="sng" dirty="0">
                 <a:latin typeface="Helvetica Neue"/>
                 <a:ea typeface="Helvetica Neue"/>
                 <a:cs typeface="Helvetica Neue"/>
@@ -13349,7 +13523,7 @@
               <a:t>Training data</a:t>
             </a:r>
             <a:br>
-              <a:rPr lang="en-CA" b="1" dirty="0">
+              <a:rPr lang="en-CA" sz="2400" b="1" dirty="0">
                 <a:latin typeface="Helvetica Neue"/>
                 <a:ea typeface="Helvetica Neue"/>
                 <a:cs typeface="Helvetica Neue"/>
@@ -13357,7 +13531,7 @@
               </a:rPr>
             </a:br>
             <a:r>
-              <a:rPr lang="en-CA" b="1" dirty="0">
+              <a:rPr lang="en-CA" sz="2400" b="1" dirty="0">
                 <a:latin typeface="Helvetica Neue"/>
                 <a:ea typeface="Helvetica Neue"/>
                 <a:cs typeface="Helvetica Neue"/>
@@ -13365,7 +13539,7 @@
               </a:rPr>
               <a:t>GWAS summary statistics</a:t>
             </a:r>
-            <a:endParaRPr dirty="0">
+            <a:endParaRPr sz="2400" dirty="0">
               <a:latin typeface="Helvetica Neue"/>
               <a:ea typeface="Helvetica Neue"/>
               <a:cs typeface="Helvetica Neue"/>
@@ -13382,7 +13556,7 @@
               </a:spcAft>
               <a:buNone/>
             </a:pPr>
-            <a:endParaRPr dirty="0">
+            <a:endParaRPr sz="2400" dirty="0">
               <a:latin typeface="Helvetica Neue"/>
               <a:ea typeface="Helvetica Neue"/>
               <a:cs typeface="Helvetica Neue"/>
@@ -13399,8 +13573,8 @@
         </p:nvSpPr>
         <p:spPr>
           <a:xfrm>
-            <a:off x="5977600" y="2056375"/>
-            <a:ext cx="2228700" cy="2228700"/>
+            <a:off x="5929668" y="1199274"/>
+            <a:ext cx="2537643" cy="2529763"/>
           </a:xfrm>
           <a:prstGeom prst="roundRect">
             <a:avLst>
@@ -13436,7 +13610,7 @@
               <a:buNone/>
             </a:pPr>
             <a:r>
-              <a:rPr lang="en-CA" b="1">
+              <a:rPr lang="en-CA" sz="2400" b="1" dirty="0">
                 <a:latin typeface="Helvetica Neue"/>
                 <a:ea typeface="Helvetica Neue"/>
                 <a:cs typeface="Helvetica Neue"/>
@@ -13444,7 +13618,7 @@
               </a:rPr>
               <a:t>Linkage disequilibrium (LD) reference panel</a:t>
             </a:r>
-            <a:endParaRPr>
+            <a:endParaRPr sz="2400" dirty="0">
               <a:latin typeface="Helvetica Neue"/>
               <a:ea typeface="Helvetica Neue"/>
               <a:cs typeface="Helvetica Neue"/>
@@ -13461,7 +13635,7 @@
               </a:spcAft>
               <a:buNone/>
             </a:pPr>
-            <a:endParaRPr>
+            <a:endParaRPr sz="2400" dirty="0">
               <a:latin typeface="Helvetica Neue"/>
               <a:ea typeface="Helvetica Neue"/>
               <a:cs typeface="Helvetica Neue"/>
@@ -13478,8 +13652,8 @@
         </p:nvSpPr>
         <p:spPr>
           <a:xfrm>
-            <a:off x="638200" y="4406550"/>
-            <a:ext cx="2157900" cy="1793100"/>
+            <a:off x="571204" y="3865626"/>
+            <a:ext cx="2433919" cy="1793100"/>
           </a:xfrm>
           <a:prstGeom prst="rect">
             <a:avLst/>
@@ -13505,7 +13679,7 @@
               <a:buNone/>
             </a:pPr>
             <a:r>
-              <a:rPr lang="en-CA" sz="1298" dirty="0">
+              <a:rPr lang="en-CA" sz="1800" dirty="0">
                 <a:solidFill>
                   <a:schemeClr val="dk1"/>
                 </a:solidFill>
@@ -13516,7 +13690,7 @@
               </a:rPr>
               <a:t>Process genetic data to keep high-quality common SNPs.</a:t>
             </a:r>
-            <a:endParaRPr sz="1298" dirty="0">
+            <a:endParaRPr sz="1800" dirty="0">
               <a:solidFill>
                 <a:schemeClr val="dk1"/>
               </a:solidFill>
@@ -13536,7 +13710,7 @@
               </a:spcAft>
               <a:buNone/>
             </a:pPr>
-            <a:endParaRPr sz="1298" dirty="0">
+            <a:endParaRPr sz="1800" dirty="0">
               <a:solidFill>
                 <a:schemeClr val="dk1"/>
               </a:solidFill>
@@ -13557,7 +13731,7 @@
               <a:buNone/>
             </a:pPr>
             <a:r>
-              <a:rPr lang="en-CA" sz="1298" dirty="0">
+              <a:rPr lang="en-CA" sz="1800" dirty="0">
                 <a:solidFill>
                   <a:schemeClr val="dk1"/>
                 </a:solidFill>
@@ -13568,7 +13742,7 @@
               </a:rPr>
               <a:t>Ancestry/population stratification check.</a:t>
             </a:r>
-            <a:endParaRPr sz="1298" dirty="0">
+            <a:endParaRPr sz="1800" dirty="0">
               <a:solidFill>
                 <a:schemeClr val="dk1"/>
               </a:solidFill>
@@ -13588,8 +13762,8 @@
         </p:nvSpPr>
         <p:spPr>
           <a:xfrm>
-            <a:off x="3338225" y="4406550"/>
-            <a:ext cx="2157900" cy="1793100"/>
+            <a:off x="3234612" y="3865626"/>
+            <a:ext cx="2674775" cy="1793100"/>
           </a:xfrm>
           <a:prstGeom prst="rect">
             <a:avLst/>
@@ -13615,7 +13789,7 @@
               <a:buNone/>
             </a:pPr>
             <a:r>
-              <a:rPr lang="en-CA" sz="1298" dirty="0">
+              <a:rPr lang="en-CA" sz="1800" dirty="0">
                 <a:solidFill>
                   <a:schemeClr val="dk1"/>
                 </a:solidFill>
@@ -13626,7 +13800,7 @@
               </a:rPr>
               <a:t>Samples from GWAS ≠ sample from target data</a:t>
             </a:r>
-            <a:endParaRPr sz="1298" dirty="0">
+            <a:endParaRPr sz="1800" dirty="0">
               <a:solidFill>
                 <a:schemeClr val="dk1"/>
               </a:solidFill>
@@ -13646,7 +13820,7 @@
               </a:spcAft>
               <a:buNone/>
             </a:pPr>
-            <a:endParaRPr sz="1298" dirty="0">
+            <a:endParaRPr sz="1800" dirty="0">
               <a:solidFill>
                 <a:schemeClr val="dk1"/>
               </a:solidFill>
@@ -13667,7 +13841,7 @@
               <a:buNone/>
             </a:pPr>
             <a:r>
-              <a:rPr lang="en-CA" sz="1298" dirty="0">
+              <a:rPr lang="en-CA" sz="1800" dirty="0">
                 <a:solidFill>
                   <a:schemeClr val="dk1"/>
                 </a:solidFill>
@@ -13678,7 +13852,7 @@
               </a:rPr>
               <a:t>Matched ancestry with target data.</a:t>
             </a:r>
-            <a:endParaRPr sz="1298" dirty="0">
+            <a:endParaRPr sz="1800" dirty="0">
               <a:solidFill>
                 <a:schemeClr val="dk1"/>
               </a:solidFill>
@@ -13698,7 +13872,7 @@
               </a:spcAft>
               <a:buNone/>
             </a:pPr>
-            <a:endParaRPr sz="1298" dirty="0">
+            <a:endParaRPr sz="1800" dirty="0">
               <a:solidFill>
                 <a:schemeClr val="dk1"/>
               </a:solidFill>
@@ -13719,7 +13893,7 @@
               <a:buNone/>
             </a:pPr>
             <a:r>
-              <a:rPr lang="en-CA" sz="1298" dirty="0">
+              <a:rPr lang="en-CA" sz="1800" dirty="0">
                 <a:solidFill>
                   <a:schemeClr val="dk1"/>
                 </a:solidFill>
@@ -13730,7 +13904,7 @@
               </a:rPr>
               <a:t>Well-powered, large sample size.</a:t>
             </a:r>
-            <a:endParaRPr sz="1298" dirty="0">
+            <a:endParaRPr sz="1800" dirty="0">
               <a:solidFill>
                 <a:schemeClr val="dk1"/>
               </a:solidFill>
@@ -13750,7 +13924,7 @@
               </a:spcAft>
               <a:buNone/>
             </a:pPr>
-            <a:endParaRPr sz="1298" dirty="0">
+            <a:endParaRPr sz="1800" dirty="0">
               <a:solidFill>
                 <a:schemeClr val="dk1"/>
               </a:solidFill>
@@ -13770,7 +13944,7 @@
               </a:spcAft>
               <a:buNone/>
             </a:pPr>
-            <a:endParaRPr sz="1298" dirty="0">
+            <a:endParaRPr sz="1800" dirty="0">
               <a:solidFill>
                 <a:schemeClr val="dk1"/>
               </a:solidFill>
@@ -13790,8 +13964,8 @@
         </p:nvSpPr>
         <p:spPr>
           <a:xfrm>
-            <a:off x="6013000" y="4457650"/>
-            <a:ext cx="2157900" cy="1793100"/>
+            <a:off x="5929667" y="3975591"/>
+            <a:ext cx="2537642" cy="1793100"/>
           </a:xfrm>
           <a:prstGeom prst="rect">
             <a:avLst/>
@@ -13817,7 +13991,7 @@
               <a:buNone/>
             </a:pPr>
             <a:r>
-              <a:rPr lang="en-CA" sz="1298" dirty="0">
+              <a:rPr lang="en-CA" sz="1800" dirty="0">
                 <a:solidFill>
                   <a:schemeClr val="dk1"/>
                 </a:solidFill>
@@ -13828,7 +14002,7 @@
               </a:rPr>
               <a:t>Correlation between SNPs.</a:t>
             </a:r>
-            <a:endParaRPr sz="1298" dirty="0">
+            <a:endParaRPr sz="1800" dirty="0">
               <a:solidFill>
                 <a:schemeClr val="dk1"/>
               </a:solidFill>
@@ -13848,7 +14022,7 @@
               </a:spcAft>
               <a:buNone/>
             </a:pPr>
-            <a:endParaRPr sz="1298" dirty="0">
+            <a:endParaRPr sz="1800" dirty="0">
               <a:solidFill>
                 <a:schemeClr val="dk1"/>
               </a:solidFill>
@@ -13869,7 +14043,7 @@
               <a:buNone/>
             </a:pPr>
             <a:r>
-              <a:rPr lang="en-CA" sz="1298" dirty="0">
+              <a:rPr lang="en-CA" sz="1800" dirty="0">
                 <a:solidFill>
                   <a:schemeClr val="dk1"/>
                 </a:solidFill>
@@ -13880,7 +14054,7 @@
               </a:rPr>
               <a:t>Ancestry of reference panel = ancestry of target data = ancestry of base data</a:t>
             </a:r>
-            <a:endParaRPr sz="1298" dirty="0">
+            <a:endParaRPr sz="1800" dirty="0">
               <a:solidFill>
                 <a:schemeClr val="dk1"/>
               </a:solidFill>
@@ -13963,11 +14137,17 @@
         <p:nvGraphicFramePr>
           <p:cNvPr id="278" name="Google Shape;278;p41"/>
           <p:cNvGraphicFramePr/>
-          <p:nvPr/>
+          <p:nvPr>
+            <p:extLst>
+              <p:ext uri="{D42A27DB-BD31-4B8C-83A1-F6EECF244321}">
+                <p14:modId xmlns:p14="http://schemas.microsoft.com/office/powerpoint/2010/main" val="1817335905"/>
+              </p:ext>
+            </p:extLst>
+          </p:nvPr>
         </p:nvGraphicFramePr>
         <p:xfrm>
-          <a:off x="680950" y="1610963"/>
-          <a:ext cx="7782075" cy="4137790"/>
+          <a:off x="371506" y="1308018"/>
+          <a:ext cx="8291574" cy="4845244"/>
         </p:xfrm>
         <a:graphic>
           <a:graphicData uri="http://schemas.openxmlformats.org/drawingml/2006/table">
@@ -13976,21 +14156,21 @@
                 <a:noFill/>
               </a:tblPr>
               <a:tblGrid>
-                <a:gridCol w="2594025">
+                <a:gridCol w="2763858">
                   <a:extLst>
                     <a:ext uri="{9D8B030D-6E8A-4147-A177-3AD203B41FA5}">
                       <a16:colId xmlns:a16="http://schemas.microsoft.com/office/drawing/2014/main" val="20000"/>
                     </a:ext>
                   </a:extLst>
                 </a:gridCol>
-                <a:gridCol w="2594025">
+                <a:gridCol w="2763858">
                   <a:extLst>
                     <a:ext uri="{9D8B030D-6E8A-4147-A177-3AD203B41FA5}">
                       <a16:colId xmlns:a16="http://schemas.microsoft.com/office/drawing/2014/main" val="20001"/>
                     </a:ext>
                   </a:extLst>
                 </a:gridCol>
-                <a:gridCol w="2594025">
+                <a:gridCol w="2763858">
                   <a:extLst>
                     <a:ext uri="{9D8B030D-6E8A-4147-A177-3AD203B41FA5}">
                       <a16:colId xmlns:a16="http://schemas.microsoft.com/office/drawing/2014/main" val="20002"/>
@@ -14017,7 +14197,7 @@
                         <a:buNone/>
                       </a:pPr>
                       <a:r>
-                        <a:rPr lang="en-CA" sz="1800" b="1" dirty="0">
+                        <a:rPr lang="en-CA" sz="2400" b="1" dirty="0">
                           <a:solidFill>
                             <a:schemeClr val="dk1"/>
                           </a:solidFill>
@@ -14028,7 +14208,7 @@
                         </a:rPr>
                         <a:t>Clumping and thresholding</a:t>
                       </a:r>
-                      <a:endParaRPr sz="1800" b="1" dirty="0"/>
+                      <a:endParaRPr sz="2400" b="1" dirty="0"/>
                     </a:p>
                   </a:txBody>
                   <a:tcPr marL="91425" marR="91425" marT="91425" marB="91425">
@@ -14088,10 +14268,10 @@
                         <a:buNone/>
                       </a:pPr>
                       <a:r>
-                        <a:rPr lang="en-CA" sz="1800" b="1"/>
+                        <a:rPr lang="en-CA" sz="2400" b="1"/>
                         <a:t>LD prediction</a:t>
                       </a:r>
-                      <a:endParaRPr sz="1800" b="1"/>
+                      <a:endParaRPr sz="2400" b="1"/>
                     </a:p>
                   </a:txBody>
                   <a:tcPr marL="91425" marR="91425" marT="91425" marB="91425">
@@ -14151,10 +14331,10 @@
                         <a:buNone/>
                       </a:pPr>
                       <a:r>
-                        <a:rPr lang="en-CA" sz="1800" b="1" dirty="0"/>
+                        <a:rPr lang="en-CA" sz="2400" b="1" dirty="0"/>
                         <a:t>Bayesian estimation of SNP effect sizes</a:t>
                       </a:r>
-                      <a:endParaRPr sz="1800" b="1" dirty="0"/>
+                      <a:endParaRPr sz="2400" b="1" dirty="0"/>
                     </a:p>
                   </a:txBody>
                   <a:tcPr marL="91425" marR="91425" marT="91425" marB="91425">
@@ -14229,7 +14409,7 @@
                         <a:buChar char="●"/>
                       </a:pPr>
                       <a:r>
-                        <a:rPr lang="en-CA" sz="1800" i="1">
+                        <a:rPr lang="en-CA" sz="2400" i="1" dirty="0">
                           <a:solidFill>
                             <a:schemeClr val="dk1"/>
                           </a:solidFill>
@@ -14238,9 +14418,21 @@
                           <a:cs typeface="Helvetica Neue"/>
                           <a:sym typeface="Helvetica Neue"/>
                         </a:rPr>
-                        <a:t>Ex.: PRSice</a:t>
+                        <a:t>Ex.: </a:t>
                       </a:r>
-                      <a:endParaRPr sz="1800" i="1">
+                      <a:r>
+                        <a:rPr lang="en-CA" sz="2400" i="1" dirty="0" err="1">
+                          <a:solidFill>
+                            <a:schemeClr val="dk1"/>
+                          </a:solidFill>
+                          <a:latin typeface="Helvetica Neue"/>
+                          <a:ea typeface="Helvetica Neue"/>
+                          <a:cs typeface="Helvetica Neue"/>
+                          <a:sym typeface="Helvetica Neue"/>
+                        </a:rPr>
+                        <a:t>PRSice</a:t>
+                      </a:r>
+                      <a:endParaRPr sz="2400" i="1" dirty="0">
                         <a:solidFill>
                           <a:schemeClr val="dk1"/>
                         </a:solidFill>
@@ -14269,7 +14461,7 @@
                         <a:buChar char="●"/>
                       </a:pPr>
                       <a:r>
-                        <a:rPr lang="en-CA" sz="1800">
+                        <a:rPr lang="en-CA" sz="2400" dirty="0">
                           <a:solidFill>
                             <a:schemeClr val="dk1"/>
                           </a:solidFill>
@@ -14280,7 +14472,7 @@
                         </a:rPr>
                         <a:t>Uses independent SNPs that are significant at a p-value threshold</a:t>
                       </a:r>
-                      <a:endParaRPr sz="1800">
+                      <a:endParaRPr sz="2400" dirty="0">
                         <a:solidFill>
                           <a:schemeClr val="dk1"/>
                         </a:solidFill>
@@ -14303,7 +14495,7 @@
                         </a:spcAft>
                         <a:buNone/>
                       </a:pPr>
-                      <a:endParaRPr sz="1800">
+                      <a:endParaRPr sz="2400" dirty="0">
                         <a:solidFill>
                           <a:schemeClr val="dk1"/>
                         </a:solidFill>
@@ -14376,7 +14568,7 @@
                         <a:buChar char="●"/>
                       </a:pPr>
                       <a:r>
-                        <a:rPr lang="en-CA" sz="1800" i="1">
+                        <a:rPr lang="en-CA" sz="2400" i="1">
                           <a:solidFill>
                             <a:schemeClr val="dk1"/>
                           </a:solidFill>
@@ -14387,7 +14579,7 @@
                         </a:rPr>
                         <a:t>Ex.: LD pred</a:t>
                       </a:r>
-                      <a:endParaRPr sz="1800" i="1">
+                      <a:endParaRPr sz="2400" i="1">
                         <a:solidFill>
                           <a:schemeClr val="dk1"/>
                         </a:solidFill>
@@ -14416,7 +14608,7 @@
                         <a:buChar char="●"/>
                       </a:pPr>
                       <a:r>
-                        <a:rPr lang="en-CA" sz="1800">
+                        <a:rPr lang="en-CA" sz="2400">
                           <a:solidFill>
                             <a:schemeClr val="dk1"/>
                           </a:solidFill>
@@ -14427,7 +14619,7 @@
                         </a:rPr>
                         <a:t>Predict effect sizes of SNPs based on LD correlation</a:t>
                       </a:r>
-                      <a:endParaRPr sz="1800">
+                      <a:endParaRPr sz="2400">
                         <a:solidFill>
                           <a:schemeClr val="dk1"/>
                         </a:solidFill>
@@ -14456,7 +14648,7 @@
                         <a:buChar char="●"/>
                       </a:pPr>
                       <a:r>
-                        <a:rPr lang="en-CA" sz="1800">
+                        <a:rPr lang="en-CA" sz="2400">
                           <a:solidFill>
                             <a:schemeClr val="dk1"/>
                           </a:solidFill>
@@ -14467,7 +14659,7 @@
                         </a:rPr>
                         <a:t>Needs an LD matrix (correlation between all SNPs)</a:t>
                       </a:r>
-                      <a:endParaRPr sz="1800">
+                      <a:endParaRPr sz="2400">
                         <a:solidFill>
                           <a:schemeClr val="dk1"/>
                         </a:solidFill>
@@ -14490,7 +14682,7 @@
                         </a:spcAft>
                         <a:buNone/>
                       </a:pPr>
-                      <a:endParaRPr sz="1800">
+                      <a:endParaRPr sz="2400">
                         <a:solidFill>
                           <a:schemeClr val="dk1"/>
                         </a:solidFill>
@@ -14562,7 +14754,7 @@
                         <a:buChar char="●"/>
                       </a:pPr>
                       <a:r>
-                        <a:rPr lang="en-CA" sz="1800" i="1" dirty="0">
+                        <a:rPr lang="en-CA" sz="2400" i="1" dirty="0">
                           <a:solidFill>
                             <a:schemeClr val="dk1"/>
                           </a:solidFill>
@@ -14574,7 +14766,7 @@
                         <a:t>Ex.: </a:t>
                       </a:r>
                       <a:r>
-                        <a:rPr lang="en-CA" sz="1800" i="1" dirty="0" err="1">
+                        <a:rPr lang="en-CA" sz="2400" i="1" dirty="0" err="1">
                           <a:solidFill>
                             <a:schemeClr val="dk1"/>
                           </a:solidFill>
@@ -14585,7 +14777,7 @@
                         </a:rPr>
                         <a:t>PRScs</a:t>
                       </a:r>
-                      <a:endParaRPr sz="1800" i="1" dirty="0">
+                      <a:endParaRPr sz="2400" i="1" dirty="0">
                         <a:solidFill>
                           <a:schemeClr val="dk1"/>
                         </a:solidFill>
@@ -14614,7 +14806,7 @@
                         <a:buChar char="●"/>
                       </a:pPr>
                       <a:r>
-                        <a:rPr lang="en-CA" sz="1800" dirty="0">
+                        <a:rPr lang="en-CA" sz="2400" dirty="0">
                           <a:solidFill>
                             <a:schemeClr val="dk1"/>
                           </a:solidFill>
@@ -14625,7 +14817,7 @@
                         </a:rPr>
                         <a:t>LD reference panel to adjust for the correlation between SNPs</a:t>
                       </a:r>
-                      <a:endParaRPr sz="1800" dirty="0">
+                      <a:endParaRPr sz="2400" dirty="0">
                         <a:solidFill>
                           <a:schemeClr val="dk1"/>
                         </a:solidFill>
@@ -14654,7 +14846,7 @@
                         <a:buChar char="●"/>
                       </a:pPr>
                       <a:r>
-                        <a:rPr lang="en-CA" sz="1800" dirty="0">
+                        <a:rPr lang="en-CA" sz="2400" dirty="0">
                           <a:solidFill>
                             <a:schemeClr val="dk1"/>
                           </a:solidFill>
@@ -14665,7 +14857,7 @@
                         </a:rPr>
                         <a:t>Adjust SNP effect sizes before computing PRS</a:t>
                       </a:r>
-                      <a:endParaRPr sz="1800" dirty="0">
+                      <a:endParaRPr sz="2400" dirty="0">
                         <a:solidFill>
                           <a:schemeClr val="dk1"/>
                         </a:solidFill>
@@ -14688,7 +14880,7 @@
                         </a:spcAft>
                         <a:buNone/>
                       </a:pPr>
-                      <a:endParaRPr sz="1800" dirty="0">
+                      <a:endParaRPr sz="2400" dirty="0">
                         <a:solidFill>
                           <a:schemeClr val="dk1"/>
                         </a:solidFill>
@@ -14785,7 +14977,7 @@
         </p:nvSpPr>
         <p:spPr>
           <a:xfrm>
-            <a:off x="519343" y="235915"/>
+            <a:off x="0" y="-235573"/>
             <a:ext cx="7995900" cy="1115700"/>
           </a:xfrm>
           <a:prstGeom prst="rect">
@@ -14831,8 +15023,8 @@
         </p:blipFill>
         <p:spPr>
           <a:xfrm>
-            <a:off x="1872050" y="1569301"/>
-            <a:ext cx="4833999" cy="5057675"/>
+            <a:off x="1457326" y="571501"/>
+            <a:ext cx="6029324" cy="6055476"/>
           </a:xfrm>
           <a:prstGeom prst="rect">
             <a:avLst/>
@@ -14940,8 +15132,8 @@
         </p:nvSpPr>
         <p:spPr>
           <a:xfrm>
-            <a:off x="519343" y="1650354"/>
-            <a:ext cx="7995900" cy="4397400"/>
+            <a:off x="185738" y="1230299"/>
+            <a:ext cx="8815387" cy="5391785"/>
           </a:xfrm>
           <a:prstGeom prst="rect">
             <a:avLst/>
@@ -14949,7 +15141,7 @@
         </p:spPr>
         <p:txBody>
           <a:bodyPr spcFirstLastPara="1" wrap="square" lIns="91425" tIns="45700" rIns="91425" bIns="45700" anchor="t" anchorCtr="0">
-            <a:normAutofit/>
+            <a:noAutofit/>
           </a:bodyPr>
           <a:lstStyle/>
           <a:p>
@@ -14964,7 +15156,7 @@
               <a:buChar char="●"/>
             </a:pPr>
             <a:r>
-              <a:rPr lang="en-US" dirty="0"/>
+              <a:rPr lang="en-US" sz="2400" dirty="0"/>
               <a:t>Removes SNPs that are missing in more than a certain proportion of samples </a:t>
             </a:r>
           </a:p>
@@ -14979,7 +15171,7 @@
               <a:buSzPts val="1800"/>
               <a:buNone/>
             </a:pPr>
-            <a:endParaRPr lang="en-US" dirty="0"/>
+            <a:endParaRPr lang="en-US" sz="2400" dirty="0"/>
           </a:p>
           <a:p>
             <a:pPr marL="457200" lvl="0" indent="-342900" algn="l" rtl="0">
@@ -14993,7 +15185,7 @@
               <a:buChar char="●"/>
             </a:pPr>
             <a:r>
-              <a:rPr lang="en-US" dirty="0"/>
+              <a:rPr lang="en-US" sz="2400" dirty="0"/>
               <a:t>Remove SNPs that are occur at extremely low frequencies</a:t>
             </a:r>
           </a:p>
@@ -15008,7 +15200,7 @@
               <a:buSzPts val="1800"/>
               <a:buChar char="●"/>
             </a:pPr>
-            <a:endParaRPr lang="en-US" dirty="0"/>
+            <a:endParaRPr lang="en-US" sz="2400" dirty="0"/>
           </a:p>
           <a:p>
             <a:pPr marL="457200" lvl="0" indent="-342900" algn="l" rtl="0">
@@ -15022,7 +15214,7 @@
               <a:buChar char="●"/>
             </a:pPr>
             <a:r>
-              <a:rPr lang="en-US" dirty="0"/>
+              <a:rPr lang="en-US" sz="2400" dirty="0"/>
               <a:t>Remove SNPs that violate Hardy-Weinberg equilibrium</a:t>
             </a:r>
           </a:p>
@@ -15037,7 +15229,7 @@
               <a:buSzPts val="1800"/>
               <a:buChar char="●"/>
             </a:pPr>
-            <a:endParaRPr lang="en-US" dirty="0"/>
+            <a:endParaRPr lang="en-US" sz="2400" dirty="0"/>
           </a:p>
           <a:p>
             <a:pPr marL="457200" lvl="0" indent="-342900" algn="l" rtl="0">
@@ -15051,7 +15243,7 @@
               <a:buChar char="●"/>
             </a:pPr>
             <a:r>
-              <a:rPr lang="en-US" dirty="0"/>
+              <a:rPr lang="en-US" sz="2400" dirty="0"/>
               <a:t>Out of all SNPs that are correlated, select only one (LD pruning)</a:t>
             </a:r>
           </a:p>
@@ -15066,7 +15258,7 @@
               <a:buSzPts val="1800"/>
               <a:buChar char="●"/>
             </a:pPr>
-            <a:endParaRPr lang="en-US" dirty="0"/>
+            <a:endParaRPr lang="en-US" sz="2400" dirty="0"/>
           </a:p>
           <a:p>
             <a:pPr marL="457200" lvl="0" indent="-342900" algn="l" rtl="0">
@@ -15080,10 +15272,10 @@
               <a:buChar char="●"/>
             </a:pPr>
             <a:r>
-              <a:rPr lang="en-US" dirty="0"/>
+              <a:rPr lang="en-US" sz="2400" dirty="0"/>
               <a:t>Remove individuals who have more than a certain portion of missing genotype </a:t>
             </a:r>
-            <a:endParaRPr dirty="0"/>
+            <a:endParaRPr sz="2400" dirty="0"/>
           </a:p>
           <a:p>
             <a:pPr marL="457200" lvl="0" indent="-342900" algn="l" rtl="0">
@@ -15096,7 +15288,7 @@
               <a:buSzPts val="1800"/>
               <a:buChar char="●"/>
             </a:pPr>
-            <a:endParaRPr lang="en-CA" dirty="0"/>
+            <a:endParaRPr lang="en-CA" sz="2400" dirty="0"/>
           </a:p>
           <a:p>
             <a:pPr marL="457200" lvl="0" indent="-342900" algn="l" rtl="0">
@@ -15109,7 +15301,7 @@
               <a:buSzPts val="1800"/>
               <a:buChar char="●"/>
             </a:pPr>
-            <a:endParaRPr lang="en-CA" dirty="0"/>
+            <a:endParaRPr lang="en-CA" sz="2400" dirty="0"/>
           </a:p>
           <a:p>
             <a:pPr marL="0" lvl="0" indent="0" algn="l" rtl="0">
@@ -15121,7 +15313,7 @@
               </a:spcAft>
               <a:buNone/>
             </a:pPr>
-            <a:endParaRPr dirty="0"/>
+            <a:endParaRPr sz="2400" dirty="0"/>
           </a:p>
         </p:txBody>
       </p:sp>
@@ -15255,10 +15447,10 @@
               <a:buAutoNum type="arabicPeriod"/>
             </a:pPr>
             <a:r>
-              <a:rPr lang="en-CA" dirty="0"/>
-              <a:t>Fundamental understanding of GWAS</a:t>
-            </a:r>
-            <a:endParaRPr dirty="0"/>
+              <a:rPr lang="en-CA" sz="2400" dirty="0"/>
+              <a:t>Fundamental understanding of GWAS.</a:t>
+            </a:r>
+            <a:endParaRPr sz="2400" dirty="0"/>
           </a:p>
           <a:p>
             <a:pPr marL="457200" lvl="0" indent="-457200" algn="l" rtl="0">
@@ -15278,10 +15470,10 @@
               <a:buAutoNum type="arabicPeriod"/>
             </a:pPr>
             <a:r>
-              <a:rPr lang="en-CA" dirty="0"/>
-              <a:t>Fundamental understanding of PRS</a:t>
-            </a:r>
-            <a:endParaRPr lang="en-US" dirty="0"/>
+              <a:rPr lang="en-CA" sz="2400" dirty="0"/>
+              <a:t>Fundamental understanding of PRS.</a:t>
+            </a:r>
+            <a:endParaRPr lang="en-US" sz="2400" dirty="0"/>
           </a:p>
           <a:p>
             <a:pPr marL="457200" lvl="0" indent="-457200" algn="l" rtl="0">
@@ -15301,7 +15493,7 @@
               <a:buAutoNum type="arabicPeriod"/>
             </a:pPr>
             <a:r>
-              <a:rPr lang="en-US" dirty="0"/>
+              <a:rPr lang="en-US" sz="2400" dirty="0"/>
               <a:t>Access and interpret GWAS summary statistics.</a:t>
             </a:r>
           </a:p>
@@ -15323,10 +15515,10 @@
               <a:buAutoNum type="arabicPeriod"/>
             </a:pPr>
             <a:r>
-              <a:rPr lang="en-CA" dirty="0"/>
+              <a:rPr lang="en-CA" sz="2400" dirty="0"/>
               <a:t>Compute PRS and interpret results.</a:t>
             </a:r>
-            <a:endParaRPr dirty="0"/>
+            <a:endParaRPr sz="2400" dirty="0"/>
           </a:p>
           <a:p>
             <a:pPr marL="457200" lvl="0" indent="-457200" algn="l" rtl="0">
@@ -15346,10 +15538,10 @@
               <a:buAutoNum type="arabicPeriod"/>
             </a:pPr>
             <a:r>
-              <a:rPr lang="en-CA" dirty="0"/>
+              <a:rPr lang="en-CA" sz="2400" dirty="0"/>
               <a:t>Understand the pitfalls and limitations of GWAS and PRS studies.</a:t>
             </a:r>
-            <a:endParaRPr dirty="0"/>
+            <a:endParaRPr sz="2400" dirty="0"/>
           </a:p>
           <a:p>
             <a:pPr marL="0" lvl="0" indent="0" algn="l" rtl="0">
@@ -15517,10 +15709,10 @@
           <a:p>
             <a:pPr algn="ctr"/>
             <a:r>
-              <a:rPr lang="en-CA" altLang="zh-CN" dirty="0"/>
+              <a:rPr lang="en-CA" altLang="zh-CN" sz="2400" dirty="0"/>
               <a:t>Part 1. Genome-wide association studies (GWAS)</a:t>
             </a:r>
-            <a:endParaRPr lang="zh-CN" altLang="en-US" dirty="0"/>
+            <a:endParaRPr lang="zh-CN" altLang="en-US" sz="2400" dirty="0"/>
           </a:p>
         </p:txBody>
       </p:sp>
@@ -15578,10 +15770,10 @@
           <a:p>
             <a:pPr algn="ctr"/>
             <a:r>
-              <a:rPr lang="en-CA" altLang="zh-CN" dirty="0"/>
+              <a:rPr lang="en-CA" altLang="zh-CN" sz="2400" dirty="0"/>
               <a:t>Part 2. Polygenic risk scores (PRS)</a:t>
             </a:r>
-            <a:endParaRPr lang="zh-CN" altLang="en-US" dirty="0"/>
+            <a:endParaRPr lang="zh-CN" altLang="en-US" sz="2400" dirty="0"/>
           </a:p>
         </p:txBody>
       </p:sp>
@@ -15639,10 +15831,10 @@
           <a:p>
             <a:pPr algn="ctr"/>
             <a:r>
-              <a:rPr lang="en-CA" altLang="zh-CN" dirty="0"/>
+              <a:rPr lang="en-CA" altLang="zh-CN" sz="2400" dirty="0"/>
               <a:t>Part 3. Tutorial for PRS of coronary artery disease</a:t>
             </a:r>
-            <a:endParaRPr lang="zh-CN" altLang="en-US" dirty="0"/>
+            <a:endParaRPr lang="zh-CN" altLang="en-US" sz="2400" dirty="0"/>
           </a:p>
         </p:txBody>
       </p:sp>
@@ -15730,7 +15922,7 @@
         </p:nvSpPr>
         <p:spPr>
           <a:xfrm>
-            <a:off x="519343" y="1650354"/>
+            <a:off x="519343" y="1230300"/>
             <a:ext cx="7995900" cy="4397400"/>
           </a:xfrm>
           <a:prstGeom prst="rect">
@@ -15754,10 +15946,10 @@
               <a:buChar char="●"/>
             </a:pPr>
             <a:r>
-              <a:rPr lang="en-CA" dirty="0"/>
+              <a:rPr lang="en-CA" sz="2400" dirty="0"/>
               <a:t>Limited clinical utility for non-European populations</a:t>
             </a:r>
-            <a:endParaRPr dirty="0"/>
+            <a:endParaRPr sz="2400" dirty="0"/>
           </a:p>
           <a:p>
             <a:pPr marL="457200" lvl="0" indent="-342900" algn="l" rtl="0">
@@ -15770,7 +15962,7 @@
               <a:buSzPts val="1800"/>
               <a:buChar char="●"/>
             </a:pPr>
-            <a:endParaRPr lang="en-CA" dirty="0"/>
+            <a:endParaRPr lang="en-CA" sz="2400" dirty="0"/>
           </a:p>
           <a:p>
             <a:pPr marL="457200" lvl="0" indent="-342900" algn="l" rtl="0">
@@ -15784,7 +15976,7 @@
               <a:buChar char="●"/>
             </a:pPr>
             <a:r>
-              <a:rPr lang="en-CA" dirty="0"/>
+              <a:rPr lang="en-CA" sz="2400" dirty="0"/>
               <a:t>Exacerbate health disparities</a:t>
             </a:r>
           </a:p>
@@ -15957,14 +16149,14 @@
               <a:buNone/>
             </a:pPr>
             <a:r>
-              <a:rPr lang="en-CA" altLang="zh-CN" sz="1800" dirty="0">
+              <a:rPr lang="en-CA" altLang="zh-CN" sz="2400" dirty="0">
                 <a:latin typeface="Helvetica Neue" panose="020B0604020202020204"/>
               </a:rPr>
               <a:t>1. PRS: estimated genetic susceptibility for a disease </a:t>
             </a:r>
           </a:p>
           <a:p>
-            <a:endParaRPr lang="en-CA" altLang="zh-CN" sz="1800" dirty="0">
+            <a:endParaRPr lang="en-CA" altLang="zh-CN" sz="2400" dirty="0">
               <a:latin typeface="Helvetica Neue" panose="020B0604020202020204"/>
             </a:endParaRPr>
           </a:p>
@@ -15973,14 +16165,14 @@
               <a:buNone/>
             </a:pPr>
             <a:r>
-              <a:rPr lang="en-CA" altLang="zh-CN" sz="1800" dirty="0">
+              <a:rPr lang="en-CA" altLang="zh-CN" sz="2400" dirty="0">
                 <a:latin typeface="Helvetica Neue" panose="020B0604020202020204"/>
               </a:rPr>
               <a:t>2. PRS weights are typically derived from GWAS summary statistics</a:t>
             </a:r>
           </a:p>
           <a:p>
-            <a:endParaRPr lang="en-CA" altLang="zh-CN" sz="1800" dirty="0">
+            <a:endParaRPr lang="en-CA" altLang="zh-CN" sz="2400" dirty="0">
               <a:latin typeface="Helvetica Neue" panose="020B0604020202020204"/>
             </a:endParaRPr>
           </a:p>
@@ -15989,12 +16181,12 @@
               <a:buNone/>
             </a:pPr>
             <a:r>
-              <a:rPr lang="en-CA" altLang="zh-CN" sz="1800" dirty="0">
+              <a:rPr lang="en-CA" altLang="zh-CN" sz="2400" dirty="0">
                 <a:latin typeface="Helvetica Neue" panose="020B0604020202020204"/>
               </a:rPr>
               <a:t>3. PRS trained on one ancestry does not perform well on another</a:t>
             </a:r>
-            <a:endParaRPr lang="zh-CN" altLang="en-US" sz="1800" dirty="0">
+            <a:endParaRPr lang="zh-CN" altLang="en-US" sz="2400" dirty="0">
               <a:latin typeface="Helvetica Neue" panose="020B0604020202020204"/>
             </a:endParaRPr>
           </a:p>
@@ -16124,7 +16316,7 @@
               <a:buNone/>
             </a:pPr>
             <a:r>
-              <a:rPr lang="en-CA" sz="1600" b="0" i="0" u="none" strike="noStrike" cap="none">
+              <a:rPr lang="en-CA" sz="1600" b="0" i="0" u="none" strike="noStrike" cap="none" dirty="0">
                 <a:solidFill>
                   <a:schemeClr val="dk1"/>
                 </a:solidFill>
@@ -16135,7 +16327,7 @@
               </a:rPr>
               <a:t>Scan the QR code to confirm you attended today’s workshop.</a:t>
             </a:r>
-            <a:endParaRPr/>
+            <a:endParaRPr dirty="0"/>
           </a:p>
         </p:txBody>
       </p:sp>
@@ -16174,7 +16366,7 @@
               <a:buNone/>
             </a:pPr>
             <a:r>
-              <a:rPr lang="en-CA" sz="1600">
+              <a:rPr lang="en-CA" sz="1600" dirty="0">
                 <a:solidFill>
                   <a:schemeClr val="dk1"/>
                 </a:solidFill>
@@ -16185,7 +16377,7 @@
               </a:rPr>
               <a:t>Fill out the feedback survey in the next 72h. </a:t>
             </a:r>
-            <a:endParaRPr/>
+            <a:endParaRPr dirty="0"/>
           </a:p>
         </p:txBody>
       </p:sp>
@@ -16507,6 +16699,46 @@
           </a:prstGeom>
         </p:spPr>
       </p:pic>
+      <p:sp>
+        <p:nvSpPr>
+          <p:cNvPr id="4" name="TextBox 3">
+            <a:extLst>
+              <a:ext uri="{FF2B5EF4-FFF2-40B4-BE49-F238E27FC236}">
+                <a16:creationId xmlns:a16="http://schemas.microsoft.com/office/drawing/2014/main" id="{174892F9-A86F-AE7F-BE61-6EFBDC11AF12}"/>
+              </a:ext>
+            </a:extLst>
+          </p:cNvPr>
+          <p:cNvSpPr txBox="1"/>
+          <p:nvPr/>
+        </p:nvSpPr>
+        <p:spPr>
+          <a:xfrm>
+            <a:off x="2358241" y="6090739"/>
+            <a:ext cx="4600574" cy="369460"/>
+          </a:xfrm>
+          <a:prstGeom prst="rect">
+            <a:avLst/>
+          </a:prstGeom>
+          <a:noFill/>
+        </p:spPr>
+        <p:txBody>
+          <a:bodyPr wrap="square">
+            <a:spAutoFit/>
+          </a:bodyPr>
+          <a:lstStyle/>
+          <a:p>
+            <a:r>
+              <a:rPr lang="en-CA" b="0" i="0" dirty="0">
+                <a:effectLst/>
+                <a:latin typeface="Aptos" panose="020B0004020202020204" pitchFamily="34" charset="0"/>
+                <a:hlinkClick r:id="rId6" tooltip="Original URL: https://tinyurl.com/QLS-MiCM-Feedback. Click or tap if you trust this link."/>
+              </a:rPr>
+              <a:t>https://tinyurl.com/QLS-MiCM-Feedback</a:t>
+            </a:r>
+            <a:endParaRPr lang="en-CA" dirty="0"/>
+          </a:p>
+        </p:txBody>
+      </p:sp>
     </p:spTree>
   </p:cSld>
   <p:clrMapOvr>
@@ -16640,10 +16872,10 @@
           <a:p>
             <a:pPr algn="ctr"/>
             <a:r>
-              <a:rPr lang="en-CA" altLang="zh-CN" dirty="0"/>
+              <a:rPr lang="en-CA" altLang="zh-CN" sz="2400" dirty="0"/>
               <a:t>Part 1. Genome-wide association studies (GWAS)</a:t>
             </a:r>
-            <a:endParaRPr lang="zh-CN" altLang="en-US" dirty="0"/>
+            <a:endParaRPr lang="zh-CN" altLang="en-US" sz="2400" dirty="0"/>
           </a:p>
         </p:txBody>
       </p:sp>
@@ -16701,10 +16933,10 @@
           <a:p>
             <a:pPr algn="ctr"/>
             <a:r>
-              <a:rPr lang="en-CA" altLang="zh-CN" dirty="0"/>
+              <a:rPr lang="en-CA" altLang="zh-CN" sz="2400" dirty="0"/>
               <a:t>Part 2. Polygenic risk scores (PRS)</a:t>
             </a:r>
-            <a:endParaRPr lang="zh-CN" altLang="en-US" dirty="0"/>
+            <a:endParaRPr lang="zh-CN" altLang="en-US" sz="2400" dirty="0"/>
           </a:p>
         </p:txBody>
       </p:sp>
@@ -16762,10 +16994,10 @@
           <a:p>
             <a:pPr algn="ctr"/>
             <a:r>
-              <a:rPr lang="en-CA" altLang="zh-CN" dirty="0"/>
+              <a:rPr lang="en-CA" altLang="zh-CN" sz="2400" dirty="0"/>
               <a:t>Part 3. Tutorial for PRS of coronary artery disease</a:t>
             </a:r>
-            <a:endParaRPr lang="zh-CN" altLang="en-US" dirty="0"/>
+            <a:endParaRPr lang="zh-CN" altLang="en-US" sz="2400" dirty="0"/>
           </a:p>
         </p:txBody>
       </p:sp>
@@ -16914,10 +17146,10 @@
           <a:p>
             <a:pPr algn="ctr"/>
             <a:r>
-              <a:rPr lang="en-CA" altLang="zh-CN" dirty="0"/>
+              <a:rPr lang="en-CA" altLang="zh-CN" sz="2400" dirty="0"/>
               <a:t>Part 1. Genome-wide association studies (GWAS)</a:t>
             </a:r>
-            <a:endParaRPr lang="zh-CN" altLang="en-US" dirty="0"/>
+            <a:endParaRPr lang="zh-CN" altLang="en-US" sz="2400" dirty="0"/>
           </a:p>
         </p:txBody>
       </p:sp>
@@ -16975,10 +17207,10 @@
           <a:p>
             <a:pPr algn="ctr"/>
             <a:r>
-              <a:rPr lang="en-CA" altLang="zh-CN" dirty="0"/>
+              <a:rPr lang="en-CA" altLang="zh-CN" sz="2400" dirty="0"/>
               <a:t>Part 2. Polygenic risk scores (PRS)</a:t>
             </a:r>
-            <a:endParaRPr lang="zh-CN" altLang="en-US" dirty="0"/>
+            <a:endParaRPr lang="zh-CN" altLang="en-US" sz="2400" dirty="0"/>
           </a:p>
         </p:txBody>
       </p:sp>
@@ -17036,10 +17268,10 @@
           <a:p>
             <a:pPr algn="ctr"/>
             <a:r>
-              <a:rPr lang="en-CA" altLang="zh-CN" dirty="0"/>
+              <a:rPr lang="en-CA" altLang="zh-CN" sz="2400" dirty="0"/>
               <a:t>Part 3. Tutorial for PRS of coronary artery disease</a:t>
             </a:r>
-            <a:endParaRPr lang="zh-CN" altLang="en-US" dirty="0"/>
+            <a:endParaRPr lang="zh-CN" altLang="en-US" sz="2400" dirty="0"/>
           </a:p>
         </p:txBody>
       </p:sp>
@@ -17178,7 +17410,7 @@
               <a:defRPr/>
             </a:pPr>
             <a:r>
-              <a:rPr lang="en-CA" altLang="zh-CN" dirty="0">
+              <a:rPr lang="en-CA" altLang="zh-CN" sz="2400" dirty="0">
                 <a:solidFill>
                   <a:prstClr val="black"/>
                 </a:solidFill>
@@ -17187,7 +17419,7 @@
               </a:rPr>
               <a:t>What are genetic variants?</a:t>
             </a:r>
-            <a:endParaRPr kumimoji="0" lang="en-CA" altLang="zh-CN" sz="1800" b="0" i="0" u="none" strike="noStrike" kern="1200" cap="none" spc="0" normalizeH="0" baseline="0" noProof="0" dirty="0">
+            <a:endParaRPr kumimoji="0" lang="en-CA" altLang="zh-CN" sz="2400" b="0" i="0" u="none" strike="noStrike" kern="1200" cap="none" spc="0" normalizeH="0" baseline="0" noProof="0" dirty="0">
               <a:ln>
                 <a:noFill/>
               </a:ln>
@@ -17226,8 +17458,8 @@
         </p:blipFill>
         <p:spPr>
           <a:xfrm>
-            <a:off x="1150651" y="2789981"/>
-            <a:ext cx="5080000" cy="1731818"/>
+            <a:off x="1211177" y="2916176"/>
+            <a:ext cx="6721646" cy="2291470"/>
           </a:xfrm>
           <a:prstGeom prst="rect">
             <a:avLst/>
@@ -17336,7 +17568,7 @@
         </p:nvSpPr>
         <p:spPr>
           <a:xfrm>
-            <a:off x="519343" y="1650354"/>
+            <a:off x="123646" y="1707039"/>
             <a:ext cx="7995900" cy="4397400"/>
           </a:xfrm>
           <a:prstGeom prst="rect">
@@ -17383,7 +17615,7 @@
                 <a:ea typeface="+mn-ea"/>
                 <a:cs typeface="+mn-cs"/>
               </a:rPr>
-              <a:t>SNP</a:t>
+              <a:t>SNP (single nucleotide polymorphism)</a:t>
             </a:r>
           </a:p>
           <a:p>
@@ -17628,7 +17860,7 @@
                 <a:ea typeface="+mn-ea"/>
                 <a:cs typeface="+mn-cs"/>
               </a:rPr>
-              <a:t>CNVs</a:t>
+              <a:t>CNVs (copy number variations)</a:t>
             </a:r>
           </a:p>
         </p:txBody>
@@ -17647,7 +17879,7 @@
         </p:nvSpPr>
         <p:spPr>
           <a:xfrm>
-            <a:off x="3440074" y="1650354"/>
+            <a:off x="4850862" y="1650354"/>
             <a:ext cx="2528256" cy="646331"/>
           </a:xfrm>
           <a:prstGeom prst="rect">
@@ -17801,7 +18033,7 @@
         </p:nvSpPr>
         <p:spPr>
           <a:xfrm>
-            <a:off x="3440074" y="2595424"/>
+            <a:off x="4850862" y="2595424"/>
             <a:ext cx="3355406" cy="646331"/>
           </a:xfrm>
           <a:prstGeom prst="rect">
@@ -17955,7 +18187,7 @@
         </p:nvSpPr>
         <p:spPr>
           <a:xfrm>
-            <a:off x="3440074" y="3669316"/>
+            <a:off x="4850862" y="3669316"/>
             <a:ext cx="4182555" cy="646331"/>
           </a:xfrm>
           <a:prstGeom prst="rect">
@@ -18176,7 +18408,7 @@
         </p:nvSpPr>
         <p:spPr>
           <a:xfrm>
-            <a:off x="519343" y="1650354"/>
+            <a:off x="519343" y="1543477"/>
             <a:ext cx="7995900" cy="4397400"/>
           </a:xfrm>
           <a:prstGeom prst="rect">
@@ -18208,7 +18440,7 @@
               <a:defRPr/>
             </a:pPr>
             <a:r>
-              <a:rPr lang="en-CA" altLang="zh-CN" dirty="0">
+              <a:rPr lang="en-CA" altLang="zh-CN" sz="2400" dirty="0">
                 <a:solidFill>
                   <a:prstClr val="black"/>
                 </a:solidFill>
@@ -18217,7 +18449,7 @@
               </a:rPr>
               <a:t>Not all variants affect phenotypes equally</a:t>
             </a:r>
-            <a:endParaRPr kumimoji="0" lang="en-CA" altLang="zh-CN" sz="1800" b="0" i="0" u="none" strike="noStrike" kern="1200" cap="none" spc="0" normalizeH="0" baseline="0" noProof="0" dirty="0">
+            <a:endParaRPr kumimoji="0" lang="en-CA" altLang="zh-CN" sz="2400" b="0" i="0" u="none" strike="noStrike" kern="1200" cap="none" spc="0" normalizeH="0" baseline="0" noProof="0" dirty="0">
               <a:ln>
                 <a:noFill/>
               </a:ln>
@@ -18263,8 +18495,8 @@
         </p:blipFill>
         <p:spPr bwMode="auto">
           <a:xfrm>
-            <a:off x="2189171" y="2783840"/>
-            <a:ext cx="4656243" cy="2948954"/>
+            <a:off x="1273215" y="2203735"/>
+            <a:ext cx="6447099" cy="4083162"/>
           </a:xfrm>
           <a:prstGeom prst="rect">
             <a:avLst/>
@@ -18411,14 +18643,14 @@
           <p:nvPr>
             <p:extLst>
               <p:ext uri="{D42A27DB-BD31-4B8C-83A1-F6EECF244321}">
-                <p14:modId xmlns:p14="http://schemas.microsoft.com/office/powerpoint/2010/main" val="1821085060"/>
+                <p14:modId xmlns:p14="http://schemas.microsoft.com/office/powerpoint/2010/main" val="3352757960"/>
               </p:ext>
             </p:extLst>
           </p:nvPr>
         </p:nvGraphicFramePr>
         <p:xfrm>
-          <a:off x="733150" y="2112150"/>
-          <a:ext cx="7782100" cy="2649668"/>
+          <a:off x="733150" y="1869263"/>
+          <a:ext cx="7782100" cy="3655508"/>
         </p:xfrm>
         <a:graphic>
           <a:graphicData uri="http://schemas.openxmlformats.org/drawingml/2006/table">
@@ -18458,10 +18690,10 @@
                         <a:buNone/>
                       </a:pPr>
                       <a:r>
-                        <a:rPr lang="en-CA" sz="1800" b="1" dirty="0"/>
+                        <a:rPr lang="en-CA" sz="2400" b="1" dirty="0"/>
                         <a:t>Mendelian traits</a:t>
                       </a:r>
-                      <a:endParaRPr sz="1800" b="1" dirty="0"/>
+                      <a:endParaRPr sz="2400" b="1" dirty="0"/>
                     </a:p>
                   </a:txBody>
                   <a:tcPr marL="91425" marR="91425" marT="91425" marB="91425">
@@ -18521,10 +18753,10 @@
                         <a:buNone/>
                       </a:pPr>
                       <a:r>
-                        <a:rPr lang="en-CA" sz="1800" b="1"/>
+                        <a:rPr lang="en-CA" sz="2400" b="1"/>
                         <a:t>Complex traits</a:t>
                       </a:r>
-                      <a:endParaRPr sz="1800" b="1"/>
+                      <a:endParaRPr sz="2400" b="1"/>
                     </a:p>
                   </a:txBody>
                   <a:tcPr marL="91425" marR="91425" marT="91425" marB="91425">
@@ -18599,7 +18831,7 @@
                         <a:buChar char="●"/>
                       </a:pPr>
                       <a:r>
-                        <a:rPr lang="en-CA" sz="1800" dirty="0">
+                        <a:rPr lang="en-CA" sz="2400" dirty="0">
                           <a:solidFill>
                             <a:schemeClr val="dk1"/>
                           </a:solidFill>
@@ -18630,7 +18862,7 @@
                         <a:buChar char="●"/>
                       </a:pPr>
                       <a:r>
-                        <a:rPr lang="en-CA" sz="1800" dirty="0">
+                        <a:rPr lang="en-CA" sz="2400" dirty="0">
                           <a:solidFill>
                             <a:schemeClr val="dk1"/>
                           </a:solidFill>
@@ -18641,7 +18873,7 @@
                         </a:rPr>
                         <a:t>Variants are often deleterious</a:t>
                       </a:r>
-                      <a:endParaRPr sz="1800" dirty="0">
+                      <a:endParaRPr sz="2400" dirty="0">
                         <a:solidFill>
                           <a:schemeClr val="dk1"/>
                         </a:solidFill>
@@ -18670,7 +18902,7 @@
                         <a:buChar char="●"/>
                       </a:pPr>
                       <a:r>
-                        <a:rPr lang="en-CA" sz="1800" dirty="0">
+                        <a:rPr lang="en-CA" sz="2400" dirty="0">
                           <a:solidFill>
                             <a:schemeClr val="dk1"/>
                           </a:solidFill>
@@ -18681,7 +18913,7 @@
                         </a:rPr>
                         <a:t>Clear inheritance pattern</a:t>
                       </a:r>
-                      <a:endParaRPr dirty="0"/>
+                      <a:endParaRPr sz="2400" dirty="0"/>
                     </a:p>
                   </a:txBody>
                   <a:tcPr marL="91425" marR="91425" marT="91425" marB="91425">
@@ -18746,7 +18978,7 @@
                         <a:buChar char="●"/>
                       </a:pPr>
                       <a:r>
-                        <a:rPr lang="en-CA" sz="1800" dirty="0">
+                        <a:rPr lang="en-CA" sz="2400" dirty="0">
                           <a:solidFill>
                             <a:schemeClr val="dk1"/>
                           </a:solidFill>
@@ -18777,7 +19009,7 @@
                         <a:buChar char="●"/>
                       </a:pPr>
                       <a:r>
-                        <a:rPr lang="en-CA" sz="1800" dirty="0">
+                        <a:rPr lang="en-CA" sz="2400" dirty="0">
                           <a:solidFill>
                             <a:schemeClr val="dk1"/>
                           </a:solidFill>
@@ -18788,7 +19020,7 @@
                         </a:rPr>
                         <a:t>Variants are often less deleterious</a:t>
                       </a:r>
-                      <a:endParaRPr sz="1800" dirty="0">
+                      <a:endParaRPr sz="2400" dirty="0">
                         <a:solidFill>
                           <a:schemeClr val="dk1"/>
                         </a:solidFill>
@@ -18817,7 +19049,7 @@
                         <a:buChar char="●"/>
                       </a:pPr>
                       <a:r>
-                        <a:rPr lang="en-CA" sz="1800" dirty="0">
+                        <a:rPr lang="en-CA" sz="2400" dirty="0">
                           <a:solidFill>
                             <a:schemeClr val="dk1"/>
                           </a:solidFill>
@@ -18848,7 +19080,7 @@
                         <a:buChar char="●"/>
                       </a:pPr>
                       <a:r>
-                        <a:rPr lang="en-CA" sz="1800" dirty="0">
+                        <a:rPr lang="en-CA" sz="2400" dirty="0">
                           <a:solidFill>
                             <a:schemeClr val="dk1"/>
                           </a:solidFill>
@@ -18859,7 +19091,7 @@
                         </a:rPr>
                         <a:t>No distinct inheritance pattern </a:t>
                       </a:r>
-                      <a:endParaRPr sz="1800" dirty="0">
+                      <a:endParaRPr sz="2400" dirty="0">
                         <a:solidFill>
                           <a:schemeClr val="dk1"/>
                         </a:solidFill>
@@ -18887,7 +19119,7 @@
                         <a:buFont typeface="Arial"/>
                         <a:buNone/>
                       </a:pPr>
-                      <a:endParaRPr sz="1800" dirty="0">
+                      <a:endParaRPr sz="2400" dirty="0">
                         <a:solidFill>
                           <a:schemeClr val="dk1"/>
                         </a:solidFill>
@@ -18907,7 +19139,7 @@
                         </a:spcAft>
                         <a:buNone/>
                       </a:pPr>
-                      <a:endParaRPr dirty="0"/>
+                      <a:endParaRPr sz="2400" dirty="0"/>
                     </a:p>
                   </a:txBody>
                   <a:tcPr marL="91425" marR="91425" marT="91425" marB="91425">

</xml_diff>